<commit_message>
Add photo frames for site visit, installation, testing, training, inauguration and maintenance
Slide 6 gets a site visit frame, slide 7 installation and testing frames,
slide 8's frame is relabelled for training, and slide 13 gets inauguration/
handover and timely maintenance frames. Carries over the reviewer's slide 3
wording change (Renewable Energy –Powered Water Facility).

Co-Authored-By: Claude Opus 5.5 <noreply@anthropic.com>
Claude-Session: https://claude.ai/code/session_01Eu7Qo1rnMt9xHtUXciHDq6
</commit_message>
<xml_diff>
--- a/presentations/Solar_RO_Implementation_Overview.pptx
+++ b/presentations/Solar_RO_Implementation_Overview.pptx
@@ -867,7 +867,7 @@
           <a:p>
             <a:r>
               <a:rPr lang="en-US" dirty="0"/>
-              <a:t>This slide answers what happens after the installers leave. The school owns the system, trained staff and local personnel run it, 12 months of maintenance and water-quality testing support its operation, and periodic visits, usage monitoring and community involvement keep it in use.</a:t>
+              <a:t>This slide answers what happens after the installers leave. The school owns the system, trained staff and local personnel run it, 12 months of maintenance and water-quality testing support its operation, and periodic visits, usage monitoring and community involvement keep it in use. The two photo frames are for the inauguration or handover and for maintenance visits.</a:t>
             </a:r>
             <a:endParaRPr lang="en-US" dirty="0"/>
           </a:p>
@@ -1395,7 +1395,7 @@
           <a:p>
             <a:r>
               <a:rPr lang="en-US" dirty="0"/>
-              <a:t>Step 1 explains how schools are chosen: transparently, using local data and a community needs assessment, against four criteria. Step 2 records the starting point at each school so that later changes can be measured.</a:t>
+              <a:t>Step 1 explains how schools are chosen: transparently, using local data and a community needs assessment, against four criteria. Step 2 records the starting point at each school, during site visits, so that later changes can be measured.</a:t>
             </a:r>
             <a:endParaRPr lang="en-US" dirty="0"/>
           </a:p>
@@ -1483,7 +1483,7 @@
           <a:p>
             <a:r>
               <a:rPr lang="en-US" dirty="0"/>
-              <a:t>Left: what happens before anyone goes on site — sourcing equipment and aligning vendors. Right: the on-site sequence at each school, ending with testing and a quality and safety check before the system is used.</a:t>
+              <a:t>Left: what happens before anyone goes on site — sourcing equipment and aligning vendors. Right: the on-site sequence at each school, ending with testing and a quality and safety check before the system is used. The two frames on the right are for installation and testing photographs.</a:t>
             </a:r>
             <a:endParaRPr lang="en-US" dirty="0"/>
           </a:p>
@@ -8440,8 +8440,8 @@
         </p:nvSpPr>
         <p:spPr>
           <a:xfrm>
-            <a:off x="548640" y="1554480"/>
-            <a:ext cx="2313432" cy="868680"/>
+            <a:off x="548640" y="1463040"/>
+            <a:ext cx="2313432" cy="731520"/>
           </a:xfrm>
           <a:prstGeom prst="homePlate">
             <a:avLst/>
@@ -8465,8 +8465,8 @@
         </p:nvSpPr>
         <p:spPr>
           <a:xfrm>
-            <a:off x="685800" y="1554480"/>
-            <a:ext cx="1627632" cy="868680"/>
+            <a:off x="685800" y="1463040"/>
+            <a:ext cx="1627632" cy="731520"/>
           </a:xfrm>
           <a:prstGeom prst="rect">
             <a:avLst/>
@@ -8482,7 +8482,7 @@
               <a:buNone/>
             </a:pPr>
             <a:r>
-              <a:rPr lang="en-US" sz="1500" b="1" dirty="0">
+              <a:rPr lang="en-US" sz="1450" b="1" dirty="0">
                 <a:solidFill>
                   <a:srgbClr val="FFFFFF"/>
                 </a:solidFill>
@@ -8492,7 +8492,7 @@
               </a:rPr>
               <a:t>Installation</a:t>
             </a:r>
-            <a:endParaRPr lang="en-US" sz="1500" dirty="0"/>
+            <a:endParaRPr lang="en-US" sz="1450" dirty="0"/>
           </a:p>
         </p:txBody>
       </p:sp>
@@ -8504,12 +8504,12 @@
         </p:nvSpPr>
         <p:spPr>
           <a:xfrm>
-            <a:off x="640080" y="2697480"/>
-            <a:ext cx="2011680" cy="2697480"/>
+            <a:off x="640080" y="2359152"/>
+            <a:ext cx="2011680" cy="1618488"/>
           </a:xfrm>
           <a:prstGeom prst="roundRect">
             <a:avLst>
-              <a:gd name="adj" fmla="val 3636"/>
+              <a:gd name="adj" fmla="val 4520"/>
             </a:avLst>
           </a:prstGeom>
           <a:solidFill>
@@ -8525,14 +8525,725 @@
       </p:sp>
       <p:sp>
         <p:nvSpPr>
-          <p:cNvPr id="7" name="Shape 5"/>
-          <p:cNvSpPr/>
-          <p:nvPr/>
-        </p:nvSpPr>
-        <p:spPr>
-          <a:xfrm>
-            <a:off x="1325880" y="2880360"/>
-            <a:ext cx="640080" cy="640080"/>
+          <p:cNvPr id="7" name="Text 5"/>
+          <p:cNvSpPr txBox="1"/>
+          <p:nvPr/>
+        </p:nvSpPr>
+        <p:spPr>
+          <a:xfrm>
+            <a:off x="749808" y="2487168"/>
+            <a:ext cx="1810512" cy="1691640"/>
+          </a:xfrm>
+          <a:prstGeom prst="rect">
+            <a:avLst/>
+          </a:prstGeom>
+          <a:noFill/>
+          <a:ln/>
+        </p:spPr>
+        <p:txBody>
+          <a:bodyPr wrap="square" lIns="0" tIns="0" rIns="0" bIns="0" rtlCol="0" anchor="t"/>
+          <a:lstStyle/>
+          <a:p>
+            <a:pPr marL="152400" indent="-152400">
+              <a:spcAft>
+                <a:spcPts val="600"/>
+              </a:spcAft>
+              <a:buSzPct val="100000"/>
+              <a:buChar char="•"/>
+            </a:pPr>
+            <a:r>
+              <a:rPr lang="en-US" sz="1250" dirty="0">
+                <a:solidFill>
+                  <a:srgbClr val="1B2B34"/>
+                </a:solidFill>
+                <a:latin typeface="Calibri" pitchFamily="34" charset="0"/>
+                <a:ea typeface="Calibri" pitchFamily="34" charset="-122"/>
+                <a:cs typeface="Calibri" pitchFamily="34" charset="-120"/>
+              </a:rPr>
+              <a:t>System installed, tested &amp; verified at each school</a:t>
+            </a:r>
+            <a:endParaRPr lang="en-US" sz="1250" dirty="0"/>
+          </a:p>
+        </p:txBody>
+      </p:sp>
+      <p:sp>
+        <p:nvSpPr>
+          <p:cNvPr id="8" name="Shape 6"/>
+          <p:cNvSpPr/>
+          <p:nvPr/>
+        </p:nvSpPr>
+        <p:spPr>
+          <a:xfrm>
+            <a:off x="2743200" y="1463040"/>
+            <a:ext cx="2313432" cy="731520"/>
+          </a:xfrm>
+          <a:prstGeom prst="chevron">
+            <a:avLst/>
+          </a:prstGeom>
+          <a:solidFill>
+            <a:srgbClr val="1B7A8C"/>
+          </a:solidFill>
+          <a:ln w="19050">
+            <a:solidFill>
+              <a:srgbClr val="FFFFFF"/>
+            </a:solidFill>
+            <a:prstDash val="solid"/>
+          </a:ln>
+        </p:spPr>
+      </p:sp>
+      <p:sp>
+        <p:nvSpPr>
+          <p:cNvPr id="9" name="Text 7"/>
+          <p:cNvSpPr txBox="1"/>
+          <p:nvPr/>
+        </p:nvSpPr>
+        <p:spPr>
+          <a:xfrm>
+            <a:off x="3154680" y="1463040"/>
+            <a:ext cx="1627632" cy="731520"/>
+          </a:xfrm>
+          <a:prstGeom prst="rect">
+            <a:avLst/>
+          </a:prstGeom>
+          <a:noFill/>
+          <a:ln/>
+        </p:spPr>
+        <p:txBody>
+          <a:bodyPr wrap="square" lIns="0" tIns="0" rIns="0" bIns="0" rtlCol="0" anchor="ctr"/>
+          <a:lstStyle/>
+          <a:p>
+            <a:pPr algn="ctr" indent="0" marL="0">
+              <a:buNone/>
+            </a:pPr>
+            <a:r>
+              <a:rPr lang="en-US" sz="1450" b="1" dirty="0">
+                <a:solidFill>
+                  <a:srgbClr val="FFFFFF"/>
+                </a:solidFill>
+                <a:latin typeface="Calibri" pitchFamily="34" charset="0"/>
+                <a:ea typeface="Calibri" pitchFamily="34" charset="-122"/>
+                <a:cs typeface="Calibri" pitchFamily="34" charset="-120"/>
+              </a:rPr>
+              <a:t>Ownership</a:t>
+            </a:r>
+            <a:endParaRPr lang="en-US" sz="1450" dirty="0"/>
+          </a:p>
+        </p:txBody>
+      </p:sp>
+      <p:sp>
+        <p:nvSpPr>
+          <p:cNvPr id="10" name="Shape 8"/>
+          <p:cNvSpPr/>
+          <p:nvPr/>
+        </p:nvSpPr>
+        <p:spPr>
+          <a:xfrm>
+            <a:off x="2834640" y="2359152"/>
+            <a:ext cx="2011680" cy="1618488"/>
+          </a:xfrm>
+          <a:prstGeom prst="roundRect">
+            <a:avLst>
+              <a:gd name="adj" fmla="val 4520"/>
+            </a:avLst>
+          </a:prstGeom>
+          <a:solidFill>
+            <a:srgbClr val="F2F5F6"/>
+          </a:solidFill>
+          <a:ln w="9525">
+            <a:solidFill>
+              <a:srgbClr val="F2F5F6"/>
+            </a:solidFill>
+            <a:prstDash val="solid"/>
+          </a:ln>
+        </p:spPr>
+      </p:sp>
+      <p:sp>
+        <p:nvSpPr>
+          <p:cNvPr id="11" name="Text 9"/>
+          <p:cNvSpPr txBox="1"/>
+          <p:nvPr/>
+        </p:nvSpPr>
+        <p:spPr>
+          <a:xfrm>
+            <a:off x="2944368" y="2487168"/>
+            <a:ext cx="1810512" cy="1691640"/>
+          </a:xfrm>
+          <a:prstGeom prst="rect">
+            <a:avLst/>
+          </a:prstGeom>
+          <a:noFill/>
+          <a:ln/>
+        </p:spPr>
+        <p:txBody>
+          <a:bodyPr wrap="square" lIns="0" tIns="0" rIns="0" bIns="0" rtlCol="0" anchor="t"/>
+          <a:lstStyle/>
+          <a:p>
+            <a:pPr marL="152400" indent="-152400">
+              <a:spcAft>
+                <a:spcPts val="600"/>
+              </a:spcAft>
+              <a:buSzPct val="100000"/>
+              <a:buChar char="•"/>
+            </a:pPr>
+            <a:r>
+              <a:rPr lang="en-US" sz="1250" dirty="0">
+                <a:solidFill>
+                  <a:srgbClr val="1B2B34"/>
+                </a:solidFill>
+                <a:latin typeface="Calibri" pitchFamily="34" charset="0"/>
+                <a:ea typeface="Calibri" pitchFamily="34" charset="-122"/>
+                <a:cs typeface="Calibri" pitchFamily="34" charset="-120"/>
+              </a:rPr>
+              <a:t>Hardware handed over to school authorities</a:t>
+            </a:r>
+            <a:endParaRPr lang="en-US" sz="1250" dirty="0"/>
+          </a:p>
+          <a:p>
+            <a:pPr marL="152400" indent="-152400">
+              <a:spcAft>
+                <a:spcPts val="600"/>
+              </a:spcAft>
+              <a:buSzPct val="100000"/>
+              <a:buChar char="•"/>
+            </a:pPr>
+            <a:r>
+              <a:rPr lang="en-US" sz="1250" dirty="0">
+                <a:solidFill>
+                  <a:srgbClr val="1B2B34"/>
+                </a:solidFill>
+                <a:latin typeface="Calibri" pitchFamily="34" charset="0"/>
+                <a:ea typeface="Calibri" pitchFamily="34" charset="-122"/>
+                <a:cs typeface="Calibri" pitchFamily="34" charset="-120"/>
+              </a:rPr>
+              <a:t>With documentation &amp; training</a:t>
+            </a:r>
+            <a:endParaRPr lang="en-US" sz="1250" dirty="0"/>
+          </a:p>
+        </p:txBody>
+      </p:sp>
+      <p:sp>
+        <p:nvSpPr>
+          <p:cNvPr id="12" name="Shape 10"/>
+          <p:cNvSpPr/>
+          <p:nvPr/>
+        </p:nvSpPr>
+        <p:spPr>
+          <a:xfrm>
+            <a:off x="4937760" y="1463040"/>
+            <a:ext cx="2313432" cy="731520"/>
+          </a:xfrm>
+          <a:prstGeom prst="chevron">
+            <a:avLst/>
+          </a:prstGeom>
+          <a:solidFill>
+            <a:srgbClr val="2F9AAE"/>
+          </a:solidFill>
+          <a:ln w="19050">
+            <a:solidFill>
+              <a:srgbClr val="FFFFFF"/>
+            </a:solidFill>
+            <a:prstDash val="solid"/>
+          </a:ln>
+        </p:spPr>
+      </p:sp>
+      <p:sp>
+        <p:nvSpPr>
+          <p:cNvPr id="13" name="Text 11"/>
+          <p:cNvSpPr txBox="1"/>
+          <p:nvPr/>
+        </p:nvSpPr>
+        <p:spPr>
+          <a:xfrm>
+            <a:off x="5349240" y="1463040"/>
+            <a:ext cx="1627632" cy="731520"/>
+          </a:xfrm>
+          <a:prstGeom prst="rect">
+            <a:avLst/>
+          </a:prstGeom>
+          <a:noFill/>
+          <a:ln/>
+        </p:spPr>
+        <p:txBody>
+          <a:bodyPr wrap="square" lIns="0" tIns="0" rIns="0" bIns="0" rtlCol="0" anchor="ctr"/>
+          <a:lstStyle/>
+          <a:p>
+            <a:pPr algn="ctr" indent="0" marL="0">
+              <a:buNone/>
+            </a:pPr>
+            <a:r>
+              <a:rPr lang="en-US" sz="1450" b="1" dirty="0">
+                <a:solidFill>
+                  <a:srgbClr val="FFFFFF"/>
+                </a:solidFill>
+                <a:latin typeface="Calibri" pitchFamily="34" charset="0"/>
+                <a:ea typeface="Calibri" pitchFamily="34" charset="-122"/>
+                <a:cs typeface="Calibri" pitchFamily="34" charset="-120"/>
+              </a:rPr>
+              <a:t>Capacity Building</a:t>
+            </a:r>
+            <a:endParaRPr lang="en-US" sz="1450" dirty="0"/>
+          </a:p>
+        </p:txBody>
+      </p:sp>
+      <p:sp>
+        <p:nvSpPr>
+          <p:cNvPr id="14" name="Shape 12"/>
+          <p:cNvSpPr/>
+          <p:nvPr/>
+        </p:nvSpPr>
+        <p:spPr>
+          <a:xfrm>
+            <a:off x="5029200" y="2359152"/>
+            <a:ext cx="2011680" cy="1618488"/>
+          </a:xfrm>
+          <a:prstGeom prst="roundRect">
+            <a:avLst>
+              <a:gd name="adj" fmla="val 4520"/>
+            </a:avLst>
+          </a:prstGeom>
+          <a:solidFill>
+            <a:srgbClr val="F2F5F6"/>
+          </a:solidFill>
+          <a:ln w="9525">
+            <a:solidFill>
+              <a:srgbClr val="F2F5F6"/>
+            </a:solidFill>
+            <a:prstDash val="solid"/>
+          </a:ln>
+        </p:spPr>
+      </p:sp>
+      <p:sp>
+        <p:nvSpPr>
+          <p:cNvPr id="15" name="Text 13"/>
+          <p:cNvSpPr txBox="1"/>
+          <p:nvPr/>
+        </p:nvSpPr>
+        <p:spPr>
+          <a:xfrm>
+            <a:off x="5138928" y="2487168"/>
+            <a:ext cx="1810512" cy="1691640"/>
+          </a:xfrm>
+          <a:prstGeom prst="rect">
+            <a:avLst/>
+          </a:prstGeom>
+          <a:noFill/>
+          <a:ln/>
+        </p:spPr>
+        <p:txBody>
+          <a:bodyPr wrap="square" lIns="0" tIns="0" rIns="0" bIns="0" rtlCol="0" anchor="t"/>
+          <a:lstStyle/>
+          <a:p>
+            <a:pPr marL="152400" indent="-152400">
+              <a:spcAft>
+                <a:spcPts val="600"/>
+              </a:spcAft>
+              <a:buSzPct val="100000"/>
+              <a:buChar char="•"/>
+            </a:pPr>
+            <a:r>
+              <a:rPr lang="en-US" sz="1250" dirty="0">
+                <a:solidFill>
+                  <a:srgbClr val="1B2B34"/>
+                </a:solidFill>
+                <a:latin typeface="Calibri" pitchFamily="34" charset="0"/>
+                <a:ea typeface="Calibri" pitchFamily="34" charset="-122"/>
+                <a:cs typeface="Calibri" pitchFamily="34" charset="-120"/>
+              </a:rPr>
+              <a:t>Teachers &amp; local staff trained to operate and maintain</a:t>
+            </a:r>
+            <a:endParaRPr lang="en-US" sz="1250" dirty="0"/>
+          </a:p>
+        </p:txBody>
+      </p:sp>
+      <p:sp>
+        <p:nvSpPr>
+          <p:cNvPr id="16" name="Shape 14"/>
+          <p:cNvSpPr/>
+          <p:nvPr/>
+        </p:nvSpPr>
+        <p:spPr>
+          <a:xfrm>
+            <a:off x="7132320" y="1463040"/>
+            <a:ext cx="2313432" cy="731520"/>
+          </a:xfrm>
+          <a:prstGeom prst="chevron">
+            <a:avLst/>
+          </a:prstGeom>
+          <a:solidFill>
+            <a:srgbClr val="B86E0C"/>
+          </a:solidFill>
+          <a:ln w="19050">
+            <a:solidFill>
+              <a:srgbClr val="FFFFFF"/>
+            </a:solidFill>
+            <a:prstDash val="solid"/>
+          </a:ln>
+        </p:spPr>
+      </p:sp>
+      <p:sp>
+        <p:nvSpPr>
+          <p:cNvPr id="17" name="Text 15"/>
+          <p:cNvSpPr txBox="1"/>
+          <p:nvPr/>
+        </p:nvSpPr>
+        <p:spPr>
+          <a:xfrm>
+            <a:off x="7543800" y="1463040"/>
+            <a:ext cx="1627632" cy="731520"/>
+          </a:xfrm>
+          <a:prstGeom prst="rect">
+            <a:avLst/>
+          </a:prstGeom>
+          <a:noFill/>
+          <a:ln/>
+        </p:spPr>
+        <p:txBody>
+          <a:bodyPr wrap="square" lIns="0" tIns="0" rIns="0" bIns="0" rtlCol="0" anchor="ctr"/>
+          <a:lstStyle/>
+          <a:p>
+            <a:pPr algn="ctr" indent="0" marL="0">
+              <a:buNone/>
+            </a:pPr>
+            <a:r>
+              <a:rPr lang="en-US" sz="1450" b="1" dirty="0">
+                <a:solidFill>
+                  <a:srgbClr val="FFFFFF"/>
+                </a:solidFill>
+                <a:latin typeface="Calibri" pitchFamily="34" charset="0"/>
+                <a:ea typeface="Calibri" pitchFamily="34" charset="-122"/>
+                <a:cs typeface="Calibri" pitchFamily="34" charset="-120"/>
+              </a:rPr>
+              <a:t>Maintenance</a:t>
+            </a:r>
+            <a:endParaRPr lang="en-US" sz="1450" dirty="0"/>
+          </a:p>
+        </p:txBody>
+      </p:sp>
+      <p:sp>
+        <p:nvSpPr>
+          <p:cNvPr id="18" name="Shape 16"/>
+          <p:cNvSpPr/>
+          <p:nvPr/>
+        </p:nvSpPr>
+        <p:spPr>
+          <a:xfrm>
+            <a:off x="7223760" y="2359152"/>
+            <a:ext cx="2011680" cy="1618488"/>
+          </a:xfrm>
+          <a:prstGeom prst="roundRect">
+            <a:avLst>
+              <a:gd name="adj" fmla="val 4520"/>
+            </a:avLst>
+          </a:prstGeom>
+          <a:solidFill>
+            <a:srgbClr val="F2F5F6"/>
+          </a:solidFill>
+          <a:ln w="9525">
+            <a:solidFill>
+              <a:srgbClr val="F2F5F6"/>
+            </a:solidFill>
+            <a:prstDash val="solid"/>
+          </a:ln>
+        </p:spPr>
+      </p:sp>
+      <p:sp>
+        <p:nvSpPr>
+          <p:cNvPr id="19" name="Text 17"/>
+          <p:cNvSpPr txBox="1"/>
+          <p:nvPr/>
+        </p:nvSpPr>
+        <p:spPr>
+          <a:xfrm>
+            <a:off x="7333488" y="2487168"/>
+            <a:ext cx="1810512" cy="1691640"/>
+          </a:xfrm>
+          <a:prstGeom prst="rect">
+            <a:avLst/>
+          </a:prstGeom>
+          <a:noFill/>
+          <a:ln/>
+        </p:spPr>
+        <p:txBody>
+          <a:bodyPr wrap="square" lIns="0" tIns="0" rIns="0" bIns="0" rtlCol="0" anchor="t"/>
+          <a:lstStyle/>
+          <a:p>
+            <a:pPr marL="152400" indent="-152400">
+              <a:spcAft>
+                <a:spcPts val="600"/>
+              </a:spcAft>
+              <a:buSzPct val="100000"/>
+              <a:buChar char="•"/>
+            </a:pPr>
+            <a:r>
+              <a:rPr lang="en-US" sz="1250" dirty="0">
+                <a:solidFill>
+                  <a:srgbClr val="1B2B34"/>
+                </a:solidFill>
+                <a:latin typeface="Calibri" pitchFamily="34" charset="0"/>
+                <a:ea typeface="Calibri" pitchFamily="34" charset="-122"/>
+                <a:cs typeface="Calibri" pitchFamily="34" charset="-120"/>
+              </a:rPr>
+              <a:t>12-month maintenance support</a:t>
+            </a:r>
+            <a:endParaRPr lang="en-US" sz="1250" dirty="0"/>
+          </a:p>
+          <a:p>
+            <a:pPr marL="152400" indent="-152400">
+              <a:spcAft>
+                <a:spcPts val="600"/>
+              </a:spcAft>
+              <a:buSzPct val="100000"/>
+              <a:buChar char="•"/>
+            </a:pPr>
+            <a:r>
+              <a:rPr lang="en-US" sz="1250" dirty="0">
+                <a:solidFill>
+                  <a:srgbClr val="1B2B34"/>
+                </a:solidFill>
+                <a:latin typeface="Calibri" pitchFamily="34" charset="0"/>
+                <a:ea typeface="Calibri" pitchFamily="34" charset="-122"/>
+                <a:cs typeface="Calibri" pitchFamily="34" charset="-120"/>
+              </a:rPr>
+              <a:t>12-month water-quality testing</a:t>
+            </a:r>
+            <a:endParaRPr lang="en-US" sz="1250" dirty="0"/>
+          </a:p>
+          <a:p>
+            <a:pPr marL="152400" indent="-152400">
+              <a:spcAft>
+                <a:spcPts val="600"/>
+              </a:spcAft>
+              <a:buSzPct val="100000"/>
+              <a:buChar char="•"/>
+            </a:pPr>
+            <a:r>
+              <a:rPr lang="en-US" sz="1250" dirty="0">
+                <a:solidFill>
+                  <a:srgbClr val="1B2B34"/>
+                </a:solidFill>
+                <a:latin typeface="Calibri" pitchFamily="34" charset="0"/>
+                <a:ea typeface="Calibri" pitchFamily="34" charset="-122"/>
+                <a:cs typeface="Calibri" pitchFamily="34" charset="-120"/>
+              </a:rPr>
+              <a:t>Local technicians for check-ups &amp; repairs</a:t>
+            </a:r>
+            <a:endParaRPr lang="en-US" sz="1250" dirty="0"/>
+          </a:p>
+        </p:txBody>
+      </p:sp>
+      <p:sp>
+        <p:nvSpPr>
+          <p:cNvPr id="20" name="Shape 18"/>
+          <p:cNvSpPr/>
+          <p:nvPr/>
+        </p:nvSpPr>
+        <p:spPr>
+          <a:xfrm>
+            <a:off x="9326880" y="1463040"/>
+            <a:ext cx="2313432" cy="731520"/>
+          </a:xfrm>
+          <a:prstGeom prst="chevron">
+            <a:avLst/>
+          </a:prstGeom>
+          <a:solidFill>
+            <a:srgbClr val="4A8A45"/>
+          </a:solidFill>
+          <a:ln w="19050">
+            <a:solidFill>
+              <a:srgbClr val="FFFFFF"/>
+            </a:solidFill>
+            <a:prstDash val="solid"/>
+          </a:ln>
+        </p:spPr>
+      </p:sp>
+      <p:sp>
+        <p:nvSpPr>
+          <p:cNvPr id="21" name="Text 19"/>
+          <p:cNvSpPr txBox="1"/>
+          <p:nvPr/>
+        </p:nvSpPr>
+        <p:spPr>
+          <a:xfrm>
+            <a:off x="9738360" y="1463040"/>
+            <a:ext cx="1627632" cy="731520"/>
+          </a:xfrm>
+          <a:prstGeom prst="rect">
+            <a:avLst/>
+          </a:prstGeom>
+          <a:noFill/>
+          <a:ln/>
+        </p:spPr>
+        <p:txBody>
+          <a:bodyPr wrap="square" lIns="0" tIns="0" rIns="0" bIns="0" rtlCol="0" anchor="ctr"/>
+          <a:lstStyle/>
+          <a:p>
+            <a:pPr algn="ctr" indent="0" marL="0">
+              <a:buNone/>
+            </a:pPr>
+            <a:r>
+              <a:rPr lang="en-US" sz="1450" b="1" dirty="0">
+                <a:solidFill>
+                  <a:srgbClr val="FFFFFF"/>
+                </a:solidFill>
+                <a:latin typeface="Calibri" pitchFamily="34" charset="0"/>
+                <a:ea typeface="Calibri" pitchFamily="34" charset="-122"/>
+                <a:cs typeface="Calibri" pitchFamily="34" charset="-120"/>
+              </a:rPr>
+              <a:t>Long-Term Use</a:t>
+            </a:r>
+            <a:endParaRPr lang="en-US" sz="1450" dirty="0"/>
+          </a:p>
+        </p:txBody>
+      </p:sp>
+      <p:sp>
+        <p:nvSpPr>
+          <p:cNvPr id="22" name="Shape 20"/>
+          <p:cNvSpPr/>
+          <p:nvPr/>
+        </p:nvSpPr>
+        <p:spPr>
+          <a:xfrm>
+            <a:off x="9418320" y="2359152"/>
+            <a:ext cx="2011680" cy="1618488"/>
+          </a:xfrm>
+          <a:prstGeom prst="roundRect">
+            <a:avLst>
+              <a:gd name="adj" fmla="val 4520"/>
+            </a:avLst>
+          </a:prstGeom>
+          <a:solidFill>
+            <a:srgbClr val="F2F5F6"/>
+          </a:solidFill>
+          <a:ln w="9525">
+            <a:solidFill>
+              <a:srgbClr val="F2F5F6"/>
+            </a:solidFill>
+            <a:prstDash val="solid"/>
+          </a:ln>
+        </p:spPr>
+      </p:sp>
+      <p:sp>
+        <p:nvSpPr>
+          <p:cNvPr id="23" name="Text 21"/>
+          <p:cNvSpPr txBox="1"/>
+          <p:nvPr/>
+        </p:nvSpPr>
+        <p:spPr>
+          <a:xfrm>
+            <a:off x="9528048" y="2487168"/>
+            <a:ext cx="1810512" cy="1691640"/>
+          </a:xfrm>
+          <a:prstGeom prst="rect">
+            <a:avLst/>
+          </a:prstGeom>
+          <a:noFill/>
+          <a:ln/>
+        </p:spPr>
+        <p:txBody>
+          <a:bodyPr wrap="square" lIns="0" tIns="0" rIns="0" bIns="0" rtlCol="0" anchor="t"/>
+          <a:lstStyle/>
+          <a:p>
+            <a:pPr marL="152400" indent="-152400">
+              <a:spcAft>
+                <a:spcPts val="600"/>
+              </a:spcAft>
+              <a:buSzPct val="100000"/>
+              <a:buChar char="•"/>
+            </a:pPr>
+            <a:r>
+              <a:rPr lang="en-US" sz="1250" dirty="0">
+                <a:solidFill>
+                  <a:srgbClr val="1B2B34"/>
+                </a:solidFill>
+                <a:latin typeface="Calibri" pitchFamily="34" charset="0"/>
+                <a:ea typeface="Calibri" pitchFamily="34" charset="-122"/>
+                <a:cs typeface="Calibri" pitchFamily="34" charset="-120"/>
+              </a:rPr>
+              <a:t>Periodic visits &amp; usage monitoring</a:t>
+            </a:r>
+            <a:endParaRPr lang="en-US" sz="1250" dirty="0"/>
+          </a:p>
+          <a:p>
+            <a:pPr marL="152400" indent="-152400">
+              <a:spcAft>
+                <a:spcPts val="600"/>
+              </a:spcAft>
+              <a:buSzPct val="100000"/>
+              <a:buChar char="•"/>
+            </a:pPr>
+            <a:r>
+              <a:rPr lang="en-US" sz="1250" dirty="0">
+                <a:solidFill>
+                  <a:srgbClr val="1B2B34"/>
+                </a:solidFill>
+                <a:latin typeface="Calibri" pitchFamily="34" charset="0"/>
+                <a:ea typeface="Calibri" pitchFamily="34" charset="-122"/>
+                <a:cs typeface="Calibri" pitchFamily="34" charset="-120"/>
+              </a:rPr>
+              <a:t>Community-led minor upkeep</a:t>
+            </a:r>
+            <a:endParaRPr lang="en-US" sz="1250" dirty="0"/>
+          </a:p>
+          <a:p>
+            <a:pPr marL="152400" indent="-152400">
+              <a:spcAft>
+                <a:spcPts val="600"/>
+              </a:spcAft>
+              <a:buSzPct val="100000"/>
+              <a:buChar char="•"/>
+            </a:pPr>
+            <a:r>
+              <a:rPr lang="en-US" sz="1250" dirty="0">
+                <a:solidFill>
+                  <a:srgbClr val="1B2B34"/>
+                </a:solidFill>
+                <a:latin typeface="Calibri" pitchFamily="34" charset="0"/>
+                <a:ea typeface="Calibri" pitchFamily="34" charset="-122"/>
+                <a:cs typeface="Calibri" pitchFamily="34" charset="-120"/>
+              </a:rPr>
+              <a:t>Hardware life of 15–20 years</a:t>
+            </a:r>
+            <a:endParaRPr lang="en-US" sz="1250" dirty="0"/>
+          </a:p>
+        </p:txBody>
+      </p:sp>
+      <p:sp>
+        <p:nvSpPr>
+          <p:cNvPr id="24" name="Shape 22"/>
+          <p:cNvSpPr/>
+          <p:nvPr/>
+        </p:nvSpPr>
+        <p:spPr>
+          <a:xfrm>
+            <a:off x="548640" y="4160520"/>
+            <a:ext cx="3429000" cy="2057400"/>
+          </a:xfrm>
+          <a:prstGeom prst="roundRect">
+            <a:avLst>
+              <a:gd name="adj" fmla="val 3556"/>
+            </a:avLst>
+          </a:prstGeom>
+          <a:solidFill>
+            <a:srgbClr val="E4F1F3"/>
+          </a:solidFill>
+          <a:ln w="9525">
+            <a:solidFill>
+              <a:srgbClr val="E4F1F3"/>
+            </a:solidFill>
+            <a:prstDash val="solid"/>
+          </a:ln>
+        </p:spPr>
+      </p:sp>
+      <p:sp>
+        <p:nvSpPr>
+          <p:cNvPr id="25" name="Shape 23"/>
+          <p:cNvSpPr/>
+          <p:nvPr/>
+        </p:nvSpPr>
+        <p:spPr>
+          <a:xfrm>
+            <a:off x="731520" y="4389120"/>
+            <a:ext cx="502920" cy="502920"/>
           </a:xfrm>
           <a:prstGeom prst="ellipse">
             <a:avLst/>
@@ -8550,7 +9261,7 @@
       </p:sp>
       <p:pic>
         <p:nvPicPr>
-          <p:cNvPr id="8" name="Image 0" descr="preencoded.png">    </p:cNvPr>
+          <p:cNvPr id="26" name="Image 0" descr="preencoded.png">    </p:cNvPr>
           <p:cNvPicPr>
             <a:picLocks noChangeAspect="1"/>
           </p:cNvPicPr>
@@ -8564,8 +9275,8 @@
         </p:blipFill>
         <p:spPr>
           <a:xfrm>
-            <a:off x="1479499" y="3033979"/>
-            <a:ext cx="332842" cy="332842"/>
+            <a:off x="852221" y="4509821"/>
+            <a:ext cx="261518" cy="261518"/>
           </a:xfrm>
           <a:prstGeom prst="rect">
             <a:avLst/>
@@ -8574,14 +9285,53 @@
       </p:pic>
       <p:sp>
         <p:nvSpPr>
-          <p:cNvPr id="9" name="Text 6"/>
-          <p:cNvSpPr txBox="1"/>
-          <p:nvPr/>
-        </p:nvSpPr>
-        <p:spPr>
-          <a:xfrm>
-            <a:off x="749808" y="3703320"/>
-            <a:ext cx="1810512" cy="1645920"/>
+          <p:cNvPr id="27" name="Text 24"/>
+          <p:cNvSpPr txBox="1"/>
+          <p:nvPr/>
+        </p:nvSpPr>
+        <p:spPr>
+          <a:xfrm>
+            <a:off x="1371600" y="4389120"/>
+            <a:ext cx="2468880" cy="502920"/>
+          </a:xfrm>
+          <a:prstGeom prst="rect">
+            <a:avLst/>
+          </a:prstGeom>
+          <a:noFill/>
+          <a:ln/>
+        </p:spPr>
+        <p:txBody>
+          <a:bodyPr wrap="square" lIns="0" tIns="0" rIns="0" bIns="0" rtlCol="0" anchor="ctr"/>
+          <a:lstStyle/>
+          <a:p>
+            <a:pPr indent="0" marL="0">
+              <a:buNone/>
+            </a:pPr>
+            <a:r>
+              <a:rPr lang="en-US" sz="1300" b="1" spc="200" kern="0" dirty="0">
+                <a:solidFill>
+                  <a:srgbClr val="0E5E6F"/>
+                </a:solidFill>
+                <a:latin typeface="Calibri" pitchFamily="34" charset="0"/>
+                <a:ea typeface="Calibri" pitchFamily="34" charset="-122"/>
+                <a:cs typeface="Calibri" pitchFamily="34" charset="-120"/>
+              </a:rPr>
+              <a:t>END STATE</a:t>
+            </a:r>
+            <a:endParaRPr lang="en-US" sz="1300" dirty="0"/>
+          </a:p>
+        </p:txBody>
+      </p:sp>
+      <p:sp>
+        <p:nvSpPr>
+          <p:cNvPr id="28" name="Text 25"/>
+          <p:cNvSpPr txBox="1"/>
+          <p:nvPr/>
+        </p:nvSpPr>
+        <p:spPr>
+          <a:xfrm>
+            <a:off x="731520" y="5074920"/>
+            <a:ext cx="3108960" cy="1005840"/>
           </a:xfrm>
           <a:prstGeom prst="rect">
             <a:avLst/>
@@ -8593,15 +9343,11 @@
           <a:bodyPr wrap="square" lIns="0" tIns="0" rIns="0" bIns="0" rtlCol="0" anchor="t"/>
           <a:lstStyle/>
           <a:p>
-            <a:pPr marL="152400" indent="-152400">
-              <a:spcAft>
-                <a:spcPts val="800"/>
-              </a:spcAft>
-              <a:buSzPct val="100000"/>
-              <a:buChar char="•"/>
-            </a:pPr>
-            <a:r>
-              <a:rPr lang="en-US" sz="1300" dirty="0">
+            <a:pPr indent="0" marL="0">
+              <a:buNone/>
+            </a:pPr>
+            <a:r>
+              <a:rPr lang="en-US" sz="1400" dirty="0">
                 <a:solidFill>
                   <a:srgbClr val="1B2B34"/>
                 </a:solidFill>
@@ -8609,131 +9355,40 @@
                 <a:ea typeface="Calibri" pitchFamily="34" charset="-122"/>
                 <a:cs typeface="Calibri" pitchFamily="34" charset="-120"/>
               </a:rPr>
-              <a:t>System installed, tested &amp; verified at each school</a:t>
-            </a:r>
-            <a:endParaRPr lang="en-US" sz="1300" dirty="0"/>
-          </a:p>
-        </p:txBody>
-      </p:sp>
-      <p:sp>
-        <p:nvSpPr>
-          <p:cNvPr id="10" name="Shape 7"/>
-          <p:cNvSpPr/>
-          <p:nvPr/>
-        </p:nvSpPr>
-        <p:spPr>
-          <a:xfrm>
-            <a:off x="2743200" y="1554480"/>
-            <a:ext cx="2313432" cy="868680"/>
-          </a:xfrm>
-          <a:prstGeom prst="chevron">
-            <a:avLst/>
-          </a:prstGeom>
-          <a:solidFill>
-            <a:srgbClr val="1B7A8C"/>
-          </a:solidFill>
-          <a:ln w="19050">
-            <a:solidFill>
-              <a:srgbClr val="FFFFFF"/>
-            </a:solidFill>
-            <a:prstDash val="solid"/>
-          </a:ln>
-        </p:spPr>
-      </p:sp>
-      <p:sp>
-        <p:nvSpPr>
-          <p:cNvPr id="11" name="Text 8"/>
-          <p:cNvSpPr txBox="1"/>
-          <p:nvPr/>
-        </p:nvSpPr>
-        <p:spPr>
-          <a:xfrm>
-            <a:off x="3154680" y="1554480"/>
-            <a:ext cx="1627632" cy="868680"/>
-          </a:xfrm>
-          <a:prstGeom prst="rect">
-            <a:avLst/>
-          </a:prstGeom>
-          <a:noFill/>
-          <a:ln/>
-        </p:spPr>
-        <p:txBody>
-          <a:bodyPr wrap="square" lIns="0" tIns="0" rIns="0" bIns="0" rtlCol="0" anchor="ctr"/>
-          <a:lstStyle/>
-          <a:p>
-            <a:pPr algn="ctr" indent="0" marL="0">
-              <a:buNone/>
-            </a:pPr>
-            <a:r>
-              <a:rPr lang="en-US" sz="1500" b="1" dirty="0">
-                <a:solidFill>
-                  <a:srgbClr val="FFFFFF"/>
-                </a:solidFill>
-                <a:latin typeface="Calibri" pitchFamily="34" charset="0"/>
-                <a:ea typeface="Calibri" pitchFamily="34" charset="-122"/>
-                <a:cs typeface="Calibri" pitchFamily="34" charset="-120"/>
-              </a:rPr>
-              <a:t>Ownership</a:t>
-            </a:r>
-            <a:endParaRPr lang="en-US" sz="1500" dirty="0"/>
-          </a:p>
-        </p:txBody>
-      </p:sp>
-      <p:sp>
-        <p:nvSpPr>
-          <p:cNvPr id="12" name="Shape 9"/>
-          <p:cNvSpPr/>
-          <p:nvPr/>
-        </p:nvSpPr>
-        <p:spPr>
-          <a:xfrm>
-            <a:off x="2834640" y="2697480"/>
-            <a:ext cx="2011680" cy="2697480"/>
-          </a:xfrm>
-          <a:prstGeom prst="roundRect">
-            <a:avLst>
-              <a:gd name="adj" fmla="val 3636"/>
-            </a:avLst>
-          </a:prstGeom>
-          <a:solidFill>
-            <a:srgbClr val="F2F5F6"/>
-          </a:solidFill>
-          <a:ln w="9525">
-            <a:solidFill>
-              <a:srgbClr val="F2F5F6"/>
-            </a:solidFill>
-            <a:prstDash val="solid"/>
-          </a:ln>
-        </p:spPr>
-      </p:sp>
-      <p:sp>
-        <p:nvSpPr>
-          <p:cNvPr id="13" name="Shape 10"/>
-          <p:cNvSpPr/>
-          <p:nvPr/>
-        </p:nvSpPr>
-        <p:spPr>
-          <a:xfrm>
-            <a:off x="3520440" y="2880360"/>
-            <a:ext cx="640080" cy="640080"/>
-          </a:xfrm>
-          <a:prstGeom prst="ellipse">
-            <a:avLst/>
-          </a:prstGeom>
-          <a:solidFill>
-            <a:srgbClr val="1B7A8C"/>
-          </a:solidFill>
-          <a:ln w="12700">
-            <a:solidFill>
-              <a:srgbClr val="1B7A8C"/>
-            </a:solidFill>
-            <a:prstDash val="solid"/>
+              <a:t>The school owns and operates the system, backed by trained staff, local technicians and an engaged community.</a:t>
+            </a:r>
+            <a:endParaRPr lang="en-US" sz="1400" dirty="0"/>
+          </a:p>
+        </p:txBody>
+      </p:sp>
+      <p:sp>
+        <p:nvSpPr>
+          <p:cNvPr id="29" name="Shape 26"/>
+          <p:cNvSpPr/>
+          <p:nvPr/>
+        </p:nvSpPr>
+        <p:spPr>
+          <a:xfrm>
+            <a:off x="4160520" y="4160520"/>
+            <a:ext cx="3648456" cy="2057400"/>
+          </a:xfrm>
+          <a:prstGeom prst="rect">
+            <a:avLst/>
+          </a:prstGeom>
+          <a:solidFill>
+            <a:srgbClr val="EEF3F4"/>
+          </a:solidFill>
+          <a:ln w="15875">
+            <a:solidFill>
+              <a:srgbClr val="8AA3AB"/>
+            </a:solidFill>
+            <a:prstDash val="dash"/>
           </a:ln>
         </p:spPr>
       </p:sp>
       <p:pic>
         <p:nvPicPr>
-          <p:cNvPr id="14" name="Image 1" descr="preencoded.png">    </p:cNvPr>
+          <p:cNvPr id="30" name="Image 1" descr="preencoded.png">    </p:cNvPr>
           <p:cNvPicPr>
             <a:picLocks noChangeAspect="1"/>
           </p:cNvPicPr>
@@ -8747,8 +9402,8 @@
         </p:blipFill>
         <p:spPr>
           <a:xfrm>
-            <a:off x="3674059" y="3033979"/>
-            <a:ext cx="332842" cy="332842"/>
+            <a:off x="5733288" y="4613148"/>
+            <a:ext cx="502920" cy="502920"/>
           </a:xfrm>
           <a:prstGeom prst="rect">
             <a:avLst/>
@@ -8757,14 +9412,14 @@
       </p:pic>
       <p:sp>
         <p:nvSpPr>
-          <p:cNvPr id="15" name="Text 11"/>
-          <p:cNvSpPr txBox="1"/>
-          <p:nvPr/>
-        </p:nvSpPr>
-        <p:spPr>
-          <a:xfrm>
-            <a:off x="2944368" y="3703320"/>
-            <a:ext cx="1810512" cy="1645920"/>
+          <p:cNvPr id="31" name="Text 27"/>
+          <p:cNvSpPr txBox="1"/>
+          <p:nvPr/>
+        </p:nvSpPr>
+        <p:spPr>
+          <a:xfrm>
+            <a:off x="4251960" y="5207508"/>
+            <a:ext cx="3465576" cy="566928"/>
           </a:xfrm>
           <a:prstGeom prst="rect">
             <a:avLst/>
@@ -8776,44 +9431,36 @@
           <a:bodyPr wrap="square" lIns="0" tIns="0" rIns="0" bIns="0" rtlCol="0" anchor="t"/>
           <a:lstStyle/>
           <a:p>
-            <a:pPr marL="152400" indent="-152400">
-              <a:spcAft>
-                <a:spcPts val="800"/>
-              </a:spcAft>
-              <a:buSzPct val="100000"/>
-              <a:buChar char="•"/>
-            </a:pPr>
-            <a:r>
-              <a:rPr lang="en-US" sz="1300" dirty="0">
-                <a:solidFill>
-                  <a:srgbClr val="1B2B34"/>
-                </a:solidFill>
-                <a:latin typeface="Calibri" pitchFamily="34" charset="0"/>
-                <a:ea typeface="Calibri" pitchFamily="34" charset="-122"/>
-                <a:cs typeface="Calibri" pitchFamily="34" charset="-120"/>
-              </a:rPr>
-              <a:t>Hardware handed over to school authorities</a:t>
+            <a:pPr algn="ctr" indent="0" marL="0">
+              <a:buNone/>
+            </a:pPr>
+            <a:r>
+              <a:rPr lang="en-US" sz="1300" b="1" dirty="0">
+                <a:solidFill>
+                  <a:srgbClr val="4E6670"/>
+                </a:solidFill>
+                <a:latin typeface="Calibri" pitchFamily="34" charset="0"/>
+                <a:ea typeface="Calibri" pitchFamily="34" charset="-122"/>
+                <a:cs typeface="Calibri" pitchFamily="34" charset="-120"/>
+              </a:rPr>
+              <a:t>Inauguration / Handover Photo</a:t>
             </a:r>
             <a:endParaRPr lang="en-US" sz="1300" dirty="0"/>
           </a:p>
           <a:p>
-            <a:pPr marL="152400" indent="-152400">
-              <a:spcAft>
-                <a:spcPts val="800"/>
-              </a:spcAft>
-              <a:buSzPct val="100000"/>
-              <a:buChar char="•"/>
-            </a:pPr>
-            <a:r>
-              <a:rPr lang="en-US" sz="1300" dirty="0">
-                <a:solidFill>
-                  <a:srgbClr val="1B2B34"/>
-                </a:solidFill>
-                <a:latin typeface="Calibri" pitchFamily="34" charset="0"/>
-                <a:ea typeface="Calibri" pitchFamily="34" charset="-122"/>
-                <a:cs typeface="Calibri" pitchFamily="34" charset="-120"/>
-              </a:rPr>
-              <a:t>With documentation &amp; training</a:t>
+            <a:pPr algn="ctr" indent="0" marL="0">
+              <a:buNone/>
+            </a:pPr>
+            <a:r>
+              <a:rPr lang="en-US" sz="1000" dirty="0">
+                <a:solidFill>
+                  <a:srgbClr val="7B8F96"/>
+                </a:solidFill>
+                <a:latin typeface="Calibri" pitchFamily="34" charset="0"/>
+                <a:ea typeface="Calibri" pitchFamily="34" charset="-122"/>
+                <a:cs typeface="Calibri" pitchFamily="34" charset="-120"/>
+              </a:rPr>
+              <a:t>Insert photo here</a:t>
             </a:r>
             <a:endParaRPr lang="en-US" sz="1300" dirty="0"/>
           </a:p>
@@ -8821,123 +9468,32 @@
       </p:sp>
       <p:sp>
         <p:nvSpPr>
-          <p:cNvPr id="16" name="Shape 12"/>
-          <p:cNvSpPr/>
-          <p:nvPr/>
-        </p:nvSpPr>
-        <p:spPr>
-          <a:xfrm>
-            <a:off x="4937760" y="1554480"/>
-            <a:ext cx="2313432" cy="868680"/>
-          </a:xfrm>
-          <a:prstGeom prst="chevron">
-            <a:avLst/>
-          </a:prstGeom>
-          <a:solidFill>
-            <a:srgbClr val="2F9AAE"/>
-          </a:solidFill>
-          <a:ln w="19050">
-            <a:solidFill>
-              <a:srgbClr val="FFFFFF"/>
-            </a:solidFill>
-            <a:prstDash val="solid"/>
-          </a:ln>
-        </p:spPr>
-      </p:sp>
-      <p:sp>
-        <p:nvSpPr>
-          <p:cNvPr id="17" name="Text 13"/>
-          <p:cNvSpPr txBox="1"/>
-          <p:nvPr/>
-        </p:nvSpPr>
-        <p:spPr>
-          <a:xfrm>
-            <a:off x="5349240" y="1554480"/>
-            <a:ext cx="1627632" cy="868680"/>
-          </a:xfrm>
-          <a:prstGeom prst="rect">
-            <a:avLst/>
-          </a:prstGeom>
-          <a:noFill/>
-          <a:ln/>
-        </p:spPr>
-        <p:txBody>
-          <a:bodyPr wrap="square" lIns="0" tIns="0" rIns="0" bIns="0" rtlCol="0" anchor="ctr"/>
-          <a:lstStyle/>
-          <a:p>
-            <a:pPr algn="ctr" indent="0" marL="0">
-              <a:buNone/>
-            </a:pPr>
-            <a:r>
-              <a:rPr lang="en-US" sz="1500" b="1" dirty="0">
-                <a:solidFill>
-                  <a:srgbClr val="FFFFFF"/>
-                </a:solidFill>
-                <a:latin typeface="Calibri" pitchFamily="34" charset="0"/>
-                <a:ea typeface="Calibri" pitchFamily="34" charset="-122"/>
-                <a:cs typeface="Calibri" pitchFamily="34" charset="-120"/>
-              </a:rPr>
-              <a:t>Capacity Building</a:t>
-            </a:r>
-            <a:endParaRPr lang="en-US" sz="1500" dirty="0"/>
-          </a:p>
-        </p:txBody>
-      </p:sp>
-      <p:sp>
-        <p:nvSpPr>
-          <p:cNvPr id="18" name="Shape 14"/>
-          <p:cNvSpPr/>
-          <p:nvPr/>
-        </p:nvSpPr>
-        <p:spPr>
-          <a:xfrm>
-            <a:off x="5029200" y="2697480"/>
-            <a:ext cx="2011680" cy="2697480"/>
-          </a:xfrm>
-          <a:prstGeom prst="roundRect">
-            <a:avLst>
-              <a:gd name="adj" fmla="val 3636"/>
-            </a:avLst>
-          </a:prstGeom>
-          <a:solidFill>
-            <a:srgbClr val="F2F5F6"/>
-          </a:solidFill>
-          <a:ln w="9525">
-            <a:solidFill>
-              <a:srgbClr val="F2F5F6"/>
-            </a:solidFill>
-            <a:prstDash val="solid"/>
-          </a:ln>
-        </p:spPr>
-      </p:sp>
-      <p:sp>
-        <p:nvSpPr>
-          <p:cNvPr id="19" name="Shape 15"/>
-          <p:cNvSpPr/>
-          <p:nvPr/>
-        </p:nvSpPr>
-        <p:spPr>
-          <a:xfrm>
-            <a:off x="5715000" y="2880360"/>
-            <a:ext cx="640080" cy="640080"/>
-          </a:xfrm>
-          <a:prstGeom prst="ellipse">
-            <a:avLst/>
-          </a:prstGeom>
-          <a:solidFill>
-            <a:srgbClr val="2F9AAE"/>
-          </a:solidFill>
-          <a:ln w="12700">
-            <a:solidFill>
-              <a:srgbClr val="2F9AAE"/>
-            </a:solidFill>
-            <a:prstDash val="solid"/>
+          <p:cNvPr id="32" name="Shape 28"/>
+          <p:cNvSpPr/>
+          <p:nvPr/>
+        </p:nvSpPr>
+        <p:spPr>
+          <a:xfrm>
+            <a:off x="7991856" y="4160520"/>
+            <a:ext cx="3648456" cy="2057400"/>
+          </a:xfrm>
+          <a:prstGeom prst="rect">
+            <a:avLst/>
+          </a:prstGeom>
+          <a:solidFill>
+            <a:srgbClr val="EEF3F4"/>
+          </a:solidFill>
+          <a:ln w="15875">
+            <a:solidFill>
+              <a:srgbClr val="8AA3AB"/>
+            </a:solidFill>
+            <a:prstDash val="dash"/>
           </a:ln>
         </p:spPr>
       </p:sp>
       <p:pic>
         <p:nvPicPr>
-          <p:cNvPr id="20" name="Image 2" descr="preencoded.png">    </p:cNvPr>
+          <p:cNvPr id="33" name="Image 2" descr="preencoded.png">    </p:cNvPr>
           <p:cNvPicPr>
             <a:picLocks noChangeAspect="1"/>
           </p:cNvPicPr>
@@ -8951,8 +9507,8 @@
         </p:blipFill>
         <p:spPr>
           <a:xfrm>
-            <a:off x="5868619" y="3033979"/>
-            <a:ext cx="332842" cy="332842"/>
+            <a:off x="9564624" y="4613148"/>
+            <a:ext cx="502920" cy="502920"/>
           </a:xfrm>
           <a:prstGeom prst="rect">
             <a:avLst/>
@@ -8961,14 +9517,14 @@
       </p:pic>
       <p:sp>
         <p:nvSpPr>
-          <p:cNvPr id="21" name="Text 16"/>
-          <p:cNvSpPr txBox="1"/>
-          <p:nvPr/>
-        </p:nvSpPr>
-        <p:spPr>
-          <a:xfrm>
-            <a:off x="5138928" y="3703320"/>
-            <a:ext cx="1810512" cy="1645920"/>
+          <p:cNvPr id="34" name="Text 29"/>
+          <p:cNvSpPr txBox="1"/>
+          <p:nvPr/>
+        </p:nvSpPr>
+        <p:spPr>
+          <a:xfrm>
+            <a:off x="8083296" y="5207508"/>
+            <a:ext cx="3465576" cy="566928"/>
           </a:xfrm>
           <a:prstGeom prst="rect">
             <a:avLst/>
@@ -8980,610 +9536,44 @@
           <a:bodyPr wrap="square" lIns="0" tIns="0" rIns="0" bIns="0" rtlCol="0" anchor="t"/>
           <a:lstStyle/>
           <a:p>
-            <a:pPr marL="152400" indent="-152400">
-              <a:spcAft>
-                <a:spcPts val="800"/>
-              </a:spcAft>
-              <a:buSzPct val="100000"/>
-              <a:buChar char="•"/>
-            </a:pPr>
-            <a:r>
-              <a:rPr lang="en-US" sz="1300" dirty="0">
-                <a:solidFill>
-                  <a:srgbClr val="1B2B34"/>
-                </a:solidFill>
-                <a:latin typeface="Calibri" pitchFamily="34" charset="0"/>
-                <a:ea typeface="Calibri" pitchFamily="34" charset="-122"/>
-                <a:cs typeface="Calibri" pitchFamily="34" charset="-120"/>
-              </a:rPr>
-              <a:t>Teachers &amp; local staff trained to operate and maintain</a:t>
+            <a:pPr algn="ctr" indent="0" marL="0">
+              <a:buNone/>
+            </a:pPr>
+            <a:r>
+              <a:rPr lang="en-US" sz="1300" b="1" dirty="0">
+                <a:solidFill>
+                  <a:srgbClr val="4E6670"/>
+                </a:solidFill>
+                <a:latin typeface="Calibri" pitchFamily="34" charset="0"/>
+                <a:ea typeface="Calibri" pitchFamily="34" charset="-122"/>
+                <a:cs typeface="Calibri" pitchFamily="34" charset="-120"/>
+              </a:rPr>
+              <a:t>Timely Maintenance Photo</a:t>
             </a:r>
             <a:endParaRPr lang="en-US" sz="1300" dirty="0"/>
           </a:p>
-        </p:txBody>
-      </p:sp>
-      <p:sp>
-        <p:nvSpPr>
-          <p:cNvPr id="22" name="Shape 17"/>
-          <p:cNvSpPr/>
-          <p:nvPr/>
-        </p:nvSpPr>
-        <p:spPr>
-          <a:xfrm>
-            <a:off x="7132320" y="1554480"/>
-            <a:ext cx="2313432" cy="868680"/>
-          </a:xfrm>
-          <a:prstGeom prst="chevron">
-            <a:avLst/>
-          </a:prstGeom>
-          <a:solidFill>
-            <a:srgbClr val="B86E0C"/>
-          </a:solidFill>
-          <a:ln w="19050">
-            <a:solidFill>
-              <a:srgbClr val="FFFFFF"/>
-            </a:solidFill>
-            <a:prstDash val="solid"/>
-          </a:ln>
-        </p:spPr>
-      </p:sp>
-      <p:sp>
-        <p:nvSpPr>
-          <p:cNvPr id="23" name="Text 18"/>
-          <p:cNvSpPr txBox="1"/>
-          <p:nvPr/>
-        </p:nvSpPr>
-        <p:spPr>
-          <a:xfrm>
-            <a:off x="7543800" y="1554480"/>
-            <a:ext cx="1627632" cy="868680"/>
-          </a:xfrm>
-          <a:prstGeom prst="rect">
-            <a:avLst/>
-          </a:prstGeom>
-          <a:noFill/>
-          <a:ln/>
-        </p:spPr>
-        <p:txBody>
-          <a:bodyPr wrap="square" lIns="0" tIns="0" rIns="0" bIns="0" rtlCol="0" anchor="ctr"/>
-          <a:lstStyle/>
           <a:p>
             <a:pPr algn="ctr" indent="0" marL="0">
               <a:buNone/>
             </a:pPr>
             <a:r>
-              <a:rPr lang="en-US" sz="1500" b="1" dirty="0">
-                <a:solidFill>
-                  <a:srgbClr val="FFFFFF"/>
-                </a:solidFill>
-                <a:latin typeface="Calibri" pitchFamily="34" charset="0"/>
-                <a:ea typeface="Calibri" pitchFamily="34" charset="-122"/>
-                <a:cs typeface="Calibri" pitchFamily="34" charset="-120"/>
-              </a:rPr>
-              <a:t>Maintenance</a:t>
-            </a:r>
-            <a:endParaRPr lang="en-US" sz="1500" dirty="0"/>
-          </a:p>
-        </p:txBody>
-      </p:sp>
-      <p:sp>
-        <p:nvSpPr>
-          <p:cNvPr id="24" name="Shape 19"/>
-          <p:cNvSpPr/>
-          <p:nvPr/>
-        </p:nvSpPr>
-        <p:spPr>
-          <a:xfrm>
-            <a:off x="7223760" y="2697480"/>
-            <a:ext cx="2011680" cy="2697480"/>
-          </a:xfrm>
-          <a:prstGeom prst="roundRect">
-            <a:avLst>
-              <a:gd name="adj" fmla="val 3636"/>
-            </a:avLst>
-          </a:prstGeom>
-          <a:solidFill>
-            <a:srgbClr val="F2F5F6"/>
-          </a:solidFill>
-          <a:ln w="9525">
-            <a:solidFill>
-              <a:srgbClr val="F2F5F6"/>
-            </a:solidFill>
-            <a:prstDash val="solid"/>
-          </a:ln>
-        </p:spPr>
-      </p:sp>
-      <p:sp>
-        <p:nvSpPr>
-          <p:cNvPr id="25" name="Shape 20"/>
-          <p:cNvSpPr/>
-          <p:nvPr/>
-        </p:nvSpPr>
-        <p:spPr>
-          <a:xfrm>
-            <a:off x="7909560" y="2880360"/>
-            <a:ext cx="640080" cy="640080"/>
-          </a:xfrm>
-          <a:prstGeom prst="ellipse">
-            <a:avLst/>
-          </a:prstGeom>
-          <a:solidFill>
-            <a:srgbClr val="B86E0C"/>
-          </a:solidFill>
-          <a:ln w="12700">
-            <a:solidFill>
-              <a:srgbClr val="B86E0C"/>
-            </a:solidFill>
-            <a:prstDash val="solid"/>
-          </a:ln>
-        </p:spPr>
-      </p:sp>
-      <p:pic>
-        <p:nvPicPr>
-          <p:cNvPr id="26" name="Image 3" descr="preencoded.png">    </p:cNvPr>
-          <p:cNvPicPr>
-            <a:picLocks noChangeAspect="1"/>
-          </p:cNvPicPr>
-          <p:nvPr/>
-        </p:nvPicPr>
-        <p:blipFill>
-          <a:blip r:embed="rId4"/>
-          <a:stretch>
-            <a:fillRect/>
-          </a:stretch>
-        </p:blipFill>
-        <p:spPr>
-          <a:xfrm>
-            <a:off x="8063179" y="3033979"/>
-            <a:ext cx="332842" cy="332842"/>
-          </a:xfrm>
-          <a:prstGeom prst="rect">
-            <a:avLst/>
-          </a:prstGeom>
-        </p:spPr>
-      </p:pic>
-      <p:sp>
-        <p:nvSpPr>
-          <p:cNvPr id="27" name="Text 21"/>
-          <p:cNvSpPr txBox="1"/>
-          <p:nvPr/>
-        </p:nvSpPr>
-        <p:spPr>
-          <a:xfrm>
-            <a:off x="7333488" y="3703320"/>
-            <a:ext cx="1810512" cy="1645920"/>
-          </a:xfrm>
-          <a:prstGeom prst="rect">
-            <a:avLst/>
-          </a:prstGeom>
-          <a:noFill/>
-          <a:ln/>
-        </p:spPr>
-        <p:txBody>
-          <a:bodyPr wrap="square" lIns="0" tIns="0" rIns="0" bIns="0" rtlCol="0" anchor="t"/>
-          <a:lstStyle/>
-          <a:p>
-            <a:pPr marL="152400" indent="-152400">
-              <a:spcAft>
-                <a:spcPts val="800"/>
-              </a:spcAft>
-              <a:buSzPct val="100000"/>
-              <a:buChar char="•"/>
-            </a:pPr>
-            <a:r>
-              <a:rPr lang="en-US" sz="1300" dirty="0">
-                <a:solidFill>
-                  <a:srgbClr val="1B2B34"/>
-                </a:solidFill>
-                <a:latin typeface="Calibri" pitchFamily="34" charset="0"/>
-                <a:ea typeface="Calibri" pitchFamily="34" charset="-122"/>
-                <a:cs typeface="Calibri" pitchFamily="34" charset="-120"/>
-              </a:rPr>
-              <a:t>12-month maintenance support</a:t>
+              <a:rPr lang="en-US" sz="1000" dirty="0">
+                <a:solidFill>
+                  <a:srgbClr val="7B8F96"/>
+                </a:solidFill>
+                <a:latin typeface="Calibri" pitchFamily="34" charset="0"/>
+                <a:ea typeface="Calibri" pitchFamily="34" charset="-122"/>
+                <a:cs typeface="Calibri" pitchFamily="34" charset="-120"/>
+              </a:rPr>
+              <a:t>Insert photo here</a:t>
             </a:r>
             <a:endParaRPr lang="en-US" sz="1300" dirty="0"/>
           </a:p>
-          <a:p>
-            <a:pPr marL="152400" indent="-152400">
-              <a:spcAft>
-                <a:spcPts val="800"/>
-              </a:spcAft>
-              <a:buSzPct val="100000"/>
-              <a:buChar char="•"/>
-            </a:pPr>
-            <a:r>
-              <a:rPr lang="en-US" sz="1300" dirty="0">
-                <a:solidFill>
-                  <a:srgbClr val="1B2B34"/>
-                </a:solidFill>
-                <a:latin typeface="Calibri" pitchFamily="34" charset="0"/>
-                <a:ea typeface="Calibri" pitchFamily="34" charset="-122"/>
-                <a:cs typeface="Calibri" pitchFamily="34" charset="-120"/>
-              </a:rPr>
-              <a:t>12-month water-quality testing</a:t>
-            </a:r>
-            <a:endParaRPr lang="en-US" sz="1300" dirty="0"/>
-          </a:p>
-          <a:p>
-            <a:pPr marL="152400" indent="-152400">
-              <a:spcAft>
-                <a:spcPts val="800"/>
-              </a:spcAft>
-              <a:buSzPct val="100000"/>
-              <a:buChar char="•"/>
-            </a:pPr>
-            <a:r>
-              <a:rPr lang="en-US" sz="1300" dirty="0">
-                <a:solidFill>
-                  <a:srgbClr val="1B2B34"/>
-                </a:solidFill>
-                <a:latin typeface="Calibri" pitchFamily="34" charset="0"/>
-                <a:ea typeface="Calibri" pitchFamily="34" charset="-122"/>
-                <a:cs typeface="Calibri" pitchFamily="34" charset="-120"/>
-              </a:rPr>
-              <a:t>Local technicians for check-ups &amp; repairs</a:t>
-            </a:r>
-            <a:endParaRPr lang="en-US" sz="1300" dirty="0"/>
-          </a:p>
-        </p:txBody>
-      </p:sp>
-      <p:sp>
-        <p:nvSpPr>
-          <p:cNvPr id="28" name="Shape 22"/>
-          <p:cNvSpPr/>
-          <p:nvPr/>
-        </p:nvSpPr>
-        <p:spPr>
-          <a:xfrm>
-            <a:off x="9326880" y="1554480"/>
-            <a:ext cx="2313432" cy="868680"/>
-          </a:xfrm>
-          <a:prstGeom prst="chevron">
-            <a:avLst/>
-          </a:prstGeom>
-          <a:solidFill>
-            <a:srgbClr val="4A8A45"/>
-          </a:solidFill>
-          <a:ln w="19050">
-            <a:solidFill>
-              <a:srgbClr val="FFFFFF"/>
-            </a:solidFill>
-            <a:prstDash val="solid"/>
-          </a:ln>
-        </p:spPr>
-      </p:sp>
-      <p:sp>
-        <p:nvSpPr>
-          <p:cNvPr id="29" name="Text 23"/>
-          <p:cNvSpPr txBox="1"/>
-          <p:nvPr/>
-        </p:nvSpPr>
-        <p:spPr>
-          <a:xfrm>
-            <a:off x="9738360" y="1554480"/>
-            <a:ext cx="1627632" cy="868680"/>
-          </a:xfrm>
-          <a:prstGeom prst="rect">
-            <a:avLst/>
-          </a:prstGeom>
-          <a:noFill/>
-          <a:ln/>
-        </p:spPr>
-        <p:txBody>
-          <a:bodyPr wrap="square" lIns="0" tIns="0" rIns="0" bIns="0" rtlCol="0" anchor="ctr"/>
-          <a:lstStyle/>
-          <a:p>
-            <a:pPr algn="ctr" indent="0" marL="0">
-              <a:buNone/>
-            </a:pPr>
-            <a:r>
-              <a:rPr lang="en-US" sz="1500" b="1" dirty="0">
-                <a:solidFill>
-                  <a:srgbClr val="FFFFFF"/>
-                </a:solidFill>
-                <a:latin typeface="Calibri" pitchFamily="34" charset="0"/>
-                <a:ea typeface="Calibri" pitchFamily="34" charset="-122"/>
-                <a:cs typeface="Calibri" pitchFamily="34" charset="-120"/>
-              </a:rPr>
-              <a:t>Long-Term Use</a:t>
-            </a:r>
-            <a:endParaRPr lang="en-US" sz="1500" dirty="0"/>
-          </a:p>
-        </p:txBody>
-      </p:sp>
-      <p:sp>
-        <p:nvSpPr>
-          <p:cNvPr id="30" name="Shape 24"/>
-          <p:cNvSpPr/>
-          <p:nvPr/>
-        </p:nvSpPr>
-        <p:spPr>
-          <a:xfrm>
-            <a:off x="9418320" y="2697480"/>
-            <a:ext cx="2011680" cy="2697480"/>
-          </a:xfrm>
-          <a:prstGeom prst="roundRect">
-            <a:avLst>
-              <a:gd name="adj" fmla="val 3636"/>
-            </a:avLst>
-          </a:prstGeom>
-          <a:solidFill>
-            <a:srgbClr val="F2F5F6"/>
-          </a:solidFill>
-          <a:ln w="9525">
-            <a:solidFill>
-              <a:srgbClr val="F2F5F6"/>
-            </a:solidFill>
-            <a:prstDash val="solid"/>
-          </a:ln>
-        </p:spPr>
-      </p:sp>
-      <p:sp>
-        <p:nvSpPr>
-          <p:cNvPr id="31" name="Shape 25"/>
-          <p:cNvSpPr/>
-          <p:nvPr/>
-        </p:nvSpPr>
-        <p:spPr>
-          <a:xfrm>
-            <a:off x="10104120" y="2880360"/>
-            <a:ext cx="640080" cy="640080"/>
-          </a:xfrm>
-          <a:prstGeom prst="ellipse">
-            <a:avLst/>
-          </a:prstGeom>
-          <a:solidFill>
-            <a:srgbClr val="4A8A45"/>
-          </a:solidFill>
-          <a:ln w="12700">
-            <a:solidFill>
-              <a:srgbClr val="4A8A45"/>
-            </a:solidFill>
-            <a:prstDash val="solid"/>
-          </a:ln>
-        </p:spPr>
-      </p:sp>
-      <p:pic>
-        <p:nvPicPr>
-          <p:cNvPr id="32" name="Image 4" descr="preencoded.png">    </p:cNvPr>
-          <p:cNvPicPr>
-            <a:picLocks noChangeAspect="1"/>
-          </p:cNvPicPr>
-          <p:nvPr/>
-        </p:nvPicPr>
-        <p:blipFill>
-          <a:blip r:embed="rId5"/>
-          <a:stretch>
-            <a:fillRect/>
-          </a:stretch>
-        </p:blipFill>
-        <p:spPr>
-          <a:xfrm>
-            <a:off x="10257739" y="3033979"/>
-            <a:ext cx="332842" cy="332842"/>
-          </a:xfrm>
-          <a:prstGeom prst="rect">
-            <a:avLst/>
-          </a:prstGeom>
-        </p:spPr>
-      </p:pic>
-      <p:sp>
-        <p:nvSpPr>
-          <p:cNvPr id="33" name="Text 26"/>
-          <p:cNvSpPr txBox="1"/>
-          <p:nvPr/>
-        </p:nvSpPr>
-        <p:spPr>
-          <a:xfrm>
-            <a:off x="9528048" y="3703320"/>
-            <a:ext cx="1810512" cy="1645920"/>
-          </a:xfrm>
-          <a:prstGeom prst="rect">
-            <a:avLst/>
-          </a:prstGeom>
-          <a:noFill/>
-          <a:ln/>
-        </p:spPr>
-        <p:txBody>
-          <a:bodyPr wrap="square" lIns="0" tIns="0" rIns="0" bIns="0" rtlCol="0" anchor="t"/>
-          <a:lstStyle/>
-          <a:p>
-            <a:pPr marL="152400" indent="-152400">
-              <a:spcAft>
-                <a:spcPts val="800"/>
-              </a:spcAft>
-              <a:buSzPct val="100000"/>
-              <a:buChar char="•"/>
-            </a:pPr>
-            <a:r>
-              <a:rPr lang="en-US" sz="1300" dirty="0">
-                <a:solidFill>
-                  <a:srgbClr val="1B2B34"/>
-                </a:solidFill>
-                <a:latin typeface="Calibri" pitchFamily="34" charset="0"/>
-                <a:ea typeface="Calibri" pitchFamily="34" charset="-122"/>
-                <a:cs typeface="Calibri" pitchFamily="34" charset="-120"/>
-              </a:rPr>
-              <a:t>Periodic visits &amp; usage monitoring</a:t>
-            </a:r>
-            <a:endParaRPr lang="en-US" sz="1300" dirty="0"/>
-          </a:p>
-          <a:p>
-            <a:pPr marL="152400" indent="-152400">
-              <a:spcAft>
-                <a:spcPts val="800"/>
-              </a:spcAft>
-              <a:buSzPct val="100000"/>
-              <a:buChar char="•"/>
-            </a:pPr>
-            <a:r>
-              <a:rPr lang="en-US" sz="1300" dirty="0">
-                <a:solidFill>
-                  <a:srgbClr val="1B2B34"/>
-                </a:solidFill>
-                <a:latin typeface="Calibri" pitchFamily="34" charset="0"/>
-                <a:ea typeface="Calibri" pitchFamily="34" charset="-122"/>
-                <a:cs typeface="Calibri" pitchFamily="34" charset="-120"/>
-              </a:rPr>
-              <a:t>Community-led minor upkeep</a:t>
-            </a:r>
-            <a:endParaRPr lang="en-US" sz="1300" dirty="0"/>
-          </a:p>
-          <a:p>
-            <a:pPr marL="152400" indent="-152400">
-              <a:spcAft>
-                <a:spcPts val="800"/>
-              </a:spcAft>
-              <a:buSzPct val="100000"/>
-              <a:buChar char="•"/>
-            </a:pPr>
-            <a:r>
-              <a:rPr lang="en-US" sz="1300" dirty="0">
-                <a:solidFill>
-                  <a:srgbClr val="1B2B34"/>
-                </a:solidFill>
-                <a:latin typeface="Calibri" pitchFamily="34" charset="0"/>
-                <a:ea typeface="Calibri" pitchFamily="34" charset="-122"/>
-                <a:cs typeface="Calibri" pitchFamily="34" charset="-120"/>
-              </a:rPr>
-              <a:t>Hardware life of 15–20 years</a:t>
-            </a:r>
-            <a:endParaRPr lang="en-US" sz="1300" dirty="0"/>
-          </a:p>
-        </p:txBody>
-      </p:sp>
-      <p:sp>
-        <p:nvSpPr>
-          <p:cNvPr id="34" name="Shape 27"/>
-          <p:cNvSpPr/>
-          <p:nvPr/>
-        </p:nvSpPr>
-        <p:spPr>
-          <a:xfrm>
-            <a:off x="548640" y="5577840"/>
-            <a:ext cx="11091672" cy="621792"/>
-          </a:xfrm>
-          <a:prstGeom prst="roundRect">
-            <a:avLst>
-              <a:gd name="adj" fmla="val 11765"/>
-            </a:avLst>
-          </a:prstGeom>
-          <a:solidFill>
-            <a:srgbClr val="E4F1F3"/>
-          </a:solidFill>
-          <a:ln w="9525">
-            <a:solidFill>
-              <a:srgbClr val="E4F1F3"/>
-            </a:solidFill>
-            <a:prstDash val="solid"/>
-          </a:ln>
-        </p:spPr>
-      </p:sp>
-      <p:sp>
-        <p:nvSpPr>
-          <p:cNvPr id="35" name="Shape 28"/>
-          <p:cNvSpPr/>
-          <p:nvPr/>
-        </p:nvSpPr>
-        <p:spPr>
-          <a:xfrm>
-            <a:off x="713232" y="5641848"/>
-            <a:ext cx="493776" cy="493776"/>
-          </a:xfrm>
-          <a:prstGeom prst="ellipse">
-            <a:avLst/>
-          </a:prstGeom>
-          <a:solidFill>
-            <a:srgbClr val="0E5E6F"/>
-          </a:solidFill>
-          <a:ln w="12700">
-            <a:solidFill>
-              <a:srgbClr val="0E5E6F"/>
-            </a:solidFill>
-            <a:prstDash val="solid"/>
-          </a:ln>
-        </p:spPr>
-      </p:sp>
-      <p:pic>
-        <p:nvPicPr>
-          <p:cNvPr id="36" name="Image 5" descr="preencoded.png">    </p:cNvPr>
-          <p:cNvPicPr>
-            <a:picLocks noChangeAspect="1"/>
-          </p:cNvPicPr>
-          <p:nvPr/>
-        </p:nvPicPr>
-        <p:blipFill>
-          <a:blip r:embed="rId6"/>
-          <a:stretch>
-            <a:fillRect/>
-          </a:stretch>
-        </p:blipFill>
-        <p:spPr>
-          <a:xfrm>
-            <a:off x="831738" y="5760354"/>
-            <a:ext cx="256764" cy="256764"/>
-          </a:xfrm>
-          <a:prstGeom prst="rect">
-            <a:avLst/>
-          </a:prstGeom>
-        </p:spPr>
-      </p:pic>
-      <p:sp>
-        <p:nvSpPr>
-          <p:cNvPr id="37" name="Text 29"/>
-          <p:cNvSpPr txBox="1"/>
-          <p:nvPr/>
-        </p:nvSpPr>
-        <p:spPr>
-          <a:xfrm>
-            <a:off x="1371600" y="5577840"/>
-            <a:ext cx="10149840" cy="621792"/>
-          </a:xfrm>
-          <a:prstGeom prst="rect">
-            <a:avLst/>
-          </a:prstGeom>
-          <a:noFill/>
-          <a:ln/>
-        </p:spPr>
-        <p:txBody>
-          <a:bodyPr wrap="square" lIns="0" tIns="0" rIns="0" bIns="0" rtlCol="0" anchor="ctr"/>
-          <a:lstStyle/>
-          <a:p>
-            <a:pPr indent="0" marL="0">
-              <a:buNone/>
-            </a:pPr>
-            <a:r>
-              <a:rPr lang="en-US" sz="1600" b="1" dirty="0">
-                <a:solidFill>
-                  <a:srgbClr val="0E5E6F"/>
-                </a:solidFill>
-                <a:latin typeface="Calibri" pitchFamily="34" charset="0"/>
-                <a:ea typeface="Calibri" pitchFamily="34" charset="-122"/>
-                <a:cs typeface="Calibri" pitchFamily="34" charset="-120"/>
-              </a:rPr>
-              <a:t>End state:  </a:t>
-            </a:r>
-            <a:pPr indent="0" marL="0">
-              <a:buNone/>
-            </a:pPr>
-            <a:r>
-              <a:rPr lang="en-US" sz="1600" dirty="0">
-                <a:solidFill>
-                  <a:srgbClr val="1B2B34"/>
-                </a:solidFill>
-                <a:latin typeface="Calibri" pitchFamily="34" charset="0"/>
-                <a:ea typeface="Calibri" pitchFamily="34" charset="-122"/>
-                <a:cs typeface="Calibri" pitchFamily="34" charset="-120"/>
-              </a:rPr>
-              <a:t>the school owns and operates the system, backed by trained staff, local technicians and an engaged community.</a:t>
-            </a:r>
-            <a:endParaRPr lang="en-US" sz="1600" dirty="0"/>
-          </a:p>
-        </p:txBody>
-      </p:sp>
-      <p:sp>
-        <p:nvSpPr>
-          <p:cNvPr id="38" name="Text 30"/>
+        </p:txBody>
+      </p:sp>
+      <p:sp>
+        <p:nvSpPr>
+          <p:cNvPr id="35" name="Text 30"/>
           <p:cNvSpPr txBox="1"/>
           <p:nvPr/>
         </p:nvSpPr>
@@ -9622,7 +9612,7 @@
       </p:sp>
       <p:sp>
         <p:nvSpPr>
-          <p:cNvPr id="39" name="Text 31"/>
+          <p:cNvPr id="36" name="Text 31"/>
           <p:cNvSpPr txBox="1"/>
           <p:nvPr/>
         </p:nvSpPr>
@@ -13930,7 +13920,7 @@
                 <a:ea typeface="Calibri" pitchFamily="34" charset="-122"/>
                 <a:cs typeface="Calibri" pitchFamily="34" charset="-120"/>
               </a:rPr>
-              <a:t>Solar-powered water coolers</a:t>
+              <a:t>Renewable Energy –Powered Water Facility</a:t>
             </a:r>
             <a:endParaRPr lang="en-US" sz="1500" dirty="0"/>
           </a:p>
@@ -19178,57 +19168,18 @@
       </p:sp>
       <p:sp>
         <p:nvSpPr>
-          <p:cNvPr id="36" name="Text 28"/>
-          <p:cNvSpPr txBox="1"/>
-          <p:nvPr/>
-        </p:nvSpPr>
-        <p:spPr>
-          <a:xfrm>
-            <a:off x="6519672" y="2240280"/>
-            <a:ext cx="4937760" cy="320040"/>
-          </a:xfrm>
-          <a:prstGeom prst="rect">
-            <a:avLst/>
-          </a:prstGeom>
-          <a:noFill/>
-          <a:ln/>
-        </p:spPr>
-        <p:txBody>
-          <a:bodyPr wrap="square" lIns="0" tIns="0" rIns="0" bIns="0" rtlCol="0" anchor="t"/>
-          <a:lstStyle/>
-          <a:p>
-            <a:pPr indent="0" marL="0">
-              <a:buNone/>
-            </a:pPr>
-            <a:r>
-              <a:rPr lang="en-US" sz="1300" i="1" dirty="0">
-                <a:solidFill>
-                  <a:srgbClr val="5B6770"/>
-                </a:solidFill>
-                <a:latin typeface="Calibri" pitchFamily="34" charset="0"/>
-                <a:ea typeface="Calibri" pitchFamily="34" charset="-122"/>
-                <a:cs typeface="Calibri" pitchFamily="34" charset="-120"/>
-              </a:rPr>
-              <a:t>Recorded at each school before installation</a:t>
-            </a:r>
-            <a:endParaRPr lang="en-US" sz="1300" dirty="0"/>
-          </a:p>
-        </p:txBody>
-      </p:sp>
-      <p:sp>
-        <p:nvSpPr>
-          <p:cNvPr id="37" name="Shape 29"/>
-          <p:cNvSpPr/>
-          <p:nvPr/>
-        </p:nvSpPr>
-        <p:spPr>
-          <a:xfrm>
-            <a:off x="6519672" y="2697480"/>
-            <a:ext cx="4892040" cy="713232"/>
+          <p:cNvPr id="36" name="Shape 28"/>
+          <p:cNvSpPr/>
+          <p:nvPr/>
+        </p:nvSpPr>
+        <p:spPr>
+          <a:xfrm>
+            <a:off x="6519672" y="2331720"/>
+            <a:ext cx="2404872" cy="658368"/>
           </a:xfrm>
           <a:prstGeom prst="roundRect">
             <a:avLst>
-              <a:gd name="adj" fmla="val 10256"/>
+              <a:gd name="adj" fmla="val 11111"/>
             </a:avLst>
           </a:prstGeom>
           <a:solidFill>
@@ -19244,14 +19195,14 @@
       </p:sp>
       <p:sp>
         <p:nvSpPr>
-          <p:cNvPr id="38" name="Shape 30"/>
-          <p:cNvSpPr/>
-          <p:nvPr/>
-        </p:nvSpPr>
-        <p:spPr>
-          <a:xfrm>
-            <a:off x="6675120" y="2825496"/>
-            <a:ext cx="457200" cy="457200"/>
+          <p:cNvPr id="37" name="Shape 29"/>
+          <p:cNvSpPr/>
+          <p:nvPr/>
+        </p:nvSpPr>
+        <p:spPr>
+          <a:xfrm>
+            <a:off x="6647688" y="2468880"/>
+            <a:ext cx="384048" cy="384048"/>
           </a:xfrm>
           <a:prstGeom prst="ellipse">
             <a:avLst/>
@@ -19269,7 +19220,7 @@
       </p:sp>
       <p:pic>
         <p:nvPicPr>
-          <p:cNvPr id="39" name="Image 6" descr="preencoded.png">    </p:cNvPr>
+          <p:cNvPr id="38" name="Image 6" descr="preencoded.png">    </p:cNvPr>
           <p:cNvPicPr>
             <a:picLocks noChangeAspect="1"/>
           </p:cNvPicPr>
@@ -19283,8 +19234,8 @@
         </p:blipFill>
         <p:spPr>
           <a:xfrm>
-            <a:off x="6798564" y="2948940"/>
-            <a:ext cx="210312" cy="210312"/>
+            <a:off x="6751381" y="2572573"/>
+            <a:ext cx="176662" cy="176662"/>
           </a:xfrm>
           <a:prstGeom prst="rect">
             <a:avLst/>
@@ -19293,14 +19244,14 @@
       </p:pic>
       <p:sp>
         <p:nvSpPr>
-          <p:cNvPr id="40" name="Text 31"/>
-          <p:cNvSpPr txBox="1"/>
-          <p:nvPr/>
-        </p:nvSpPr>
-        <p:spPr>
-          <a:xfrm>
-            <a:off x="7315200" y="2697480"/>
-            <a:ext cx="4023360" cy="713232"/>
+          <p:cNvPr id="39" name="Text 30"/>
+          <p:cNvSpPr txBox="1"/>
+          <p:nvPr/>
+        </p:nvSpPr>
+        <p:spPr>
+          <a:xfrm>
+            <a:off x="7123176" y="2331720"/>
+            <a:ext cx="1737360" cy="658368"/>
           </a:xfrm>
           <a:prstGeom prst="rect">
             <a:avLst/>
@@ -19316,7 +19267,7 @@
               <a:buNone/>
             </a:pPr>
             <a:r>
-              <a:rPr lang="en-US" sz="1600" b="1" dirty="0">
+              <a:rPr lang="en-US" sz="1350" b="1" dirty="0">
                 <a:solidFill>
                   <a:srgbClr val="1B2B34"/>
                 </a:solidFill>
@@ -19326,24 +19277,24 @@
               </a:rPr>
               <a:t>School infrastructure status</a:t>
             </a:r>
-            <a:endParaRPr lang="en-US" sz="1600" dirty="0"/>
-          </a:p>
-        </p:txBody>
-      </p:sp>
-      <p:sp>
-        <p:nvSpPr>
-          <p:cNvPr id="41" name="Shape 32"/>
-          <p:cNvSpPr/>
-          <p:nvPr/>
-        </p:nvSpPr>
-        <p:spPr>
-          <a:xfrm>
-            <a:off x="6519672" y="3538728"/>
-            <a:ext cx="4892040" cy="713232"/>
+            <a:endParaRPr lang="en-US" sz="1350" dirty="0"/>
+          </a:p>
+        </p:txBody>
+      </p:sp>
+      <p:sp>
+        <p:nvSpPr>
+          <p:cNvPr id="40" name="Shape 31"/>
+          <p:cNvSpPr/>
+          <p:nvPr/>
+        </p:nvSpPr>
+        <p:spPr>
+          <a:xfrm>
+            <a:off x="9006840" y="2331720"/>
+            <a:ext cx="2404872" cy="658368"/>
           </a:xfrm>
           <a:prstGeom prst="roundRect">
             <a:avLst>
-              <a:gd name="adj" fmla="val 10256"/>
+              <a:gd name="adj" fmla="val 11111"/>
             </a:avLst>
           </a:prstGeom>
           <a:solidFill>
@@ -19359,14 +19310,14 @@
       </p:sp>
       <p:sp>
         <p:nvSpPr>
-          <p:cNvPr id="42" name="Shape 33"/>
-          <p:cNvSpPr/>
-          <p:nvPr/>
-        </p:nvSpPr>
-        <p:spPr>
-          <a:xfrm>
-            <a:off x="6675120" y="3666744"/>
-            <a:ext cx="457200" cy="457200"/>
+          <p:cNvPr id="41" name="Shape 32"/>
+          <p:cNvSpPr/>
+          <p:nvPr/>
+        </p:nvSpPr>
+        <p:spPr>
+          <a:xfrm>
+            <a:off x="9134856" y="2468880"/>
+            <a:ext cx="384048" cy="384048"/>
           </a:xfrm>
           <a:prstGeom prst="ellipse">
             <a:avLst/>
@@ -19384,7 +19335,7 @@
       </p:sp>
       <p:pic>
         <p:nvPicPr>
-          <p:cNvPr id="43" name="Image 7" descr="preencoded.png">    </p:cNvPr>
+          <p:cNvPr id="42" name="Image 7" descr="preencoded.png">    </p:cNvPr>
           <p:cNvPicPr>
             <a:picLocks noChangeAspect="1"/>
           </p:cNvPicPr>
@@ -19398,8 +19349,8 @@
         </p:blipFill>
         <p:spPr>
           <a:xfrm>
-            <a:off x="6798564" y="3790188"/>
-            <a:ext cx="210312" cy="210312"/>
+            <a:off x="9238549" y="2572573"/>
+            <a:ext cx="176662" cy="176662"/>
           </a:xfrm>
           <a:prstGeom prst="rect">
             <a:avLst/>
@@ -19408,14 +19359,14 @@
       </p:pic>
       <p:sp>
         <p:nvSpPr>
-          <p:cNvPr id="44" name="Text 34"/>
-          <p:cNvSpPr txBox="1"/>
-          <p:nvPr/>
-        </p:nvSpPr>
-        <p:spPr>
-          <a:xfrm>
-            <a:off x="7315200" y="3538728"/>
-            <a:ext cx="4023360" cy="713232"/>
+          <p:cNvPr id="43" name="Text 33"/>
+          <p:cNvSpPr txBox="1"/>
+          <p:nvPr/>
+        </p:nvSpPr>
+        <p:spPr>
+          <a:xfrm>
+            <a:off x="9610344" y="2331720"/>
+            <a:ext cx="1737360" cy="658368"/>
           </a:xfrm>
           <a:prstGeom prst="rect">
             <a:avLst/>
@@ -19431,7 +19382,7 @@
               <a:buNone/>
             </a:pPr>
             <a:r>
-              <a:rPr lang="en-US" sz="1600" b="1" dirty="0">
+              <a:rPr lang="en-US" sz="1350" b="1" dirty="0">
                 <a:solidFill>
                   <a:srgbClr val="1B2B34"/>
                 </a:solidFill>
@@ -19441,24 +19392,24 @@
               </a:rPr>
               <a:t>Student strength / attendance</a:t>
             </a:r>
-            <a:endParaRPr lang="en-US" sz="1600" dirty="0"/>
-          </a:p>
-        </p:txBody>
-      </p:sp>
-      <p:sp>
-        <p:nvSpPr>
-          <p:cNvPr id="45" name="Shape 35"/>
-          <p:cNvSpPr/>
-          <p:nvPr/>
-        </p:nvSpPr>
-        <p:spPr>
-          <a:xfrm>
-            <a:off x="6519672" y="4379976"/>
-            <a:ext cx="4892040" cy="713232"/>
+            <a:endParaRPr lang="en-US" sz="1350" dirty="0"/>
+          </a:p>
+        </p:txBody>
+      </p:sp>
+      <p:sp>
+        <p:nvSpPr>
+          <p:cNvPr id="44" name="Shape 34"/>
+          <p:cNvSpPr/>
+          <p:nvPr/>
+        </p:nvSpPr>
+        <p:spPr>
+          <a:xfrm>
+            <a:off x="6519672" y="3108960"/>
+            <a:ext cx="2404872" cy="658368"/>
           </a:xfrm>
           <a:prstGeom prst="roundRect">
             <a:avLst>
-              <a:gd name="adj" fmla="val 10256"/>
+              <a:gd name="adj" fmla="val 11111"/>
             </a:avLst>
           </a:prstGeom>
           <a:solidFill>
@@ -19474,14 +19425,14 @@
       </p:sp>
       <p:sp>
         <p:nvSpPr>
-          <p:cNvPr id="46" name="Shape 36"/>
-          <p:cNvSpPr/>
-          <p:nvPr/>
-        </p:nvSpPr>
-        <p:spPr>
-          <a:xfrm>
-            <a:off x="6675120" y="4507992"/>
-            <a:ext cx="457200" cy="457200"/>
+          <p:cNvPr id="45" name="Shape 35"/>
+          <p:cNvSpPr/>
+          <p:nvPr/>
+        </p:nvSpPr>
+        <p:spPr>
+          <a:xfrm>
+            <a:off x="6647688" y="3246120"/>
+            <a:ext cx="384048" cy="384048"/>
           </a:xfrm>
           <a:prstGeom prst="ellipse">
             <a:avLst/>
@@ -19499,7 +19450,7 @@
       </p:sp>
       <p:pic>
         <p:nvPicPr>
-          <p:cNvPr id="47" name="Image 8" descr="preencoded.png">    </p:cNvPr>
+          <p:cNvPr id="46" name="Image 8" descr="preencoded.png">    </p:cNvPr>
           <p:cNvPicPr>
             <a:picLocks noChangeAspect="1"/>
           </p:cNvPicPr>
@@ -19513,8 +19464,8 @@
         </p:blipFill>
         <p:spPr>
           <a:xfrm>
-            <a:off x="6798564" y="4631436"/>
-            <a:ext cx="210312" cy="210312"/>
+            <a:off x="6751381" y="3349813"/>
+            <a:ext cx="176662" cy="176662"/>
           </a:xfrm>
           <a:prstGeom prst="rect">
             <a:avLst/>
@@ -19523,14 +19474,14 @@
       </p:pic>
       <p:sp>
         <p:nvSpPr>
-          <p:cNvPr id="48" name="Text 37"/>
-          <p:cNvSpPr txBox="1"/>
-          <p:nvPr/>
-        </p:nvSpPr>
-        <p:spPr>
-          <a:xfrm>
-            <a:off x="7315200" y="4379976"/>
-            <a:ext cx="4023360" cy="713232"/>
+          <p:cNvPr id="47" name="Text 36"/>
+          <p:cNvSpPr txBox="1"/>
+          <p:nvPr/>
+        </p:nvSpPr>
+        <p:spPr>
+          <a:xfrm>
+            <a:off x="7123176" y="3108960"/>
+            <a:ext cx="1737360" cy="658368"/>
           </a:xfrm>
           <a:prstGeom prst="rect">
             <a:avLst/>
@@ -19546,7 +19497,7 @@
               <a:buNone/>
             </a:pPr>
             <a:r>
-              <a:rPr lang="en-US" sz="1600" b="1" dirty="0">
+              <a:rPr lang="en-US" sz="1350" b="1" dirty="0">
                 <a:solidFill>
                   <a:srgbClr val="1B2B34"/>
                 </a:solidFill>
@@ -19556,24 +19507,24 @@
               </a:rPr>
               <a:t>Water quality</a:t>
             </a:r>
-            <a:endParaRPr lang="en-US" sz="1600" dirty="0"/>
-          </a:p>
-        </p:txBody>
-      </p:sp>
-      <p:sp>
-        <p:nvSpPr>
-          <p:cNvPr id="49" name="Shape 38"/>
-          <p:cNvSpPr/>
-          <p:nvPr/>
-        </p:nvSpPr>
-        <p:spPr>
-          <a:xfrm>
-            <a:off x="6519672" y="5221224"/>
-            <a:ext cx="4892040" cy="713232"/>
+            <a:endParaRPr lang="en-US" sz="1350" dirty="0"/>
+          </a:p>
+        </p:txBody>
+      </p:sp>
+      <p:sp>
+        <p:nvSpPr>
+          <p:cNvPr id="48" name="Shape 37"/>
+          <p:cNvSpPr/>
+          <p:nvPr/>
+        </p:nvSpPr>
+        <p:spPr>
+          <a:xfrm>
+            <a:off x="9006840" y="3108960"/>
+            <a:ext cx="2404872" cy="658368"/>
           </a:xfrm>
           <a:prstGeom prst="roundRect">
             <a:avLst>
-              <a:gd name="adj" fmla="val 10256"/>
+              <a:gd name="adj" fmla="val 11111"/>
             </a:avLst>
           </a:prstGeom>
           <a:solidFill>
@@ -19589,14 +19540,14 @@
       </p:sp>
       <p:sp>
         <p:nvSpPr>
-          <p:cNvPr id="50" name="Shape 39"/>
-          <p:cNvSpPr/>
-          <p:nvPr/>
-        </p:nvSpPr>
-        <p:spPr>
-          <a:xfrm>
-            <a:off x="6675120" y="5349240"/>
-            <a:ext cx="457200" cy="457200"/>
+          <p:cNvPr id="49" name="Shape 38"/>
+          <p:cNvSpPr/>
+          <p:nvPr/>
+        </p:nvSpPr>
+        <p:spPr>
+          <a:xfrm>
+            <a:off x="9134856" y="3246120"/>
+            <a:ext cx="384048" cy="384048"/>
           </a:xfrm>
           <a:prstGeom prst="ellipse">
             <a:avLst/>
@@ -19614,7 +19565,7 @@
       </p:sp>
       <p:pic>
         <p:nvPicPr>
-          <p:cNvPr id="51" name="Image 9" descr="preencoded.png">    </p:cNvPr>
+          <p:cNvPr id="50" name="Image 9" descr="preencoded.png">    </p:cNvPr>
           <p:cNvPicPr>
             <a:picLocks noChangeAspect="1"/>
           </p:cNvPicPr>
@@ -19628,8 +19579,8 @@
         </p:blipFill>
         <p:spPr>
           <a:xfrm>
-            <a:off x="6798564" y="5472684"/>
-            <a:ext cx="210312" cy="210312"/>
+            <a:off x="9238549" y="3349813"/>
+            <a:ext cx="176662" cy="176662"/>
           </a:xfrm>
           <a:prstGeom prst="rect">
             <a:avLst/>
@@ -19638,14 +19589,14 @@
       </p:pic>
       <p:sp>
         <p:nvSpPr>
-          <p:cNvPr id="52" name="Text 40"/>
-          <p:cNvSpPr txBox="1"/>
-          <p:nvPr/>
-        </p:nvSpPr>
-        <p:spPr>
-          <a:xfrm>
-            <a:off x="7315200" y="5221224"/>
-            <a:ext cx="4023360" cy="713232"/>
+          <p:cNvPr id="51" name="Text 39"/>
+          <p:cNvSpPr txBox="1"/>
+          <p:nvPr/>
+        </p:nvSpPr>
+        <p:spPr>
+          <a:xfrm>
+            <a:off x="9610344" y="3108960"/>
+            <a:ext cx="1737360" cy="658368"/>
           </a:xfrm>
           <a:prstGeom prst="rect">
             <a:avLst/>
@@ -19661,7 +19612,7 @@
               <a:buNone/>
             </a:pPr>
             <a:r>
-              <a:rPr lang="en-US" sz="1600" b="1" dirty="0">
+              <a:rPr lang="en-US" sz="1350" b="1" dirty="0">
                 <a:solidFill>
                   <a:srgbClr val="1B2B34"/>
                 </a:solidFill>
@@ -19671,13 +19622,118 @@
               </a:rPr>
               <a:t>Existing water source</a:t>
             </a:r>
-            <a:endParaRPr lang="en-US" sz="1600" dirty="0"/>
-          </a:p>
-        </p:txBody>
-      </p:sp>
-      <p:sp>
-        <p:nvSpPr>
-          <p:cNvPr id="53" name="Text 41"/>
+            <a:endParaRPr lang="en-US" sz="1350" dirty="0"/>
+          </a:p>
+        </p:txBody>
+      </p:sp>
+      <p:sp>
+        <p:nvSpPr>
+          <p:cNvPr id="52" name="Shape 40"/>
+          <p:cNvSpPr/>
+          <p:nvPr/>
+        </p:nvSpPr>
+        <p:spPr>
+          <a:xfrm>
+            <a:off x="6519672" y="3977640"/>
+            <a:ext cx="4892040" cy="2011680"/>
+          </a:xfrm>
+          <a:prstGeom prst="rect">
+            <a:avLst/>
+          </a:prstGeom>
+          <a:solidFill>
+            <a:srgbClr val="EEF3F4"/>
+          </a:solidFill>
+          <a:ln w="15875">
+            <a:solidFill>
+              <a:srgbClr val="8AA3AB"/>
+            </a:solidFill>
+            <a:prstDash val="dash"/>
+          </a:ln>
+        </p:spPr>
+      </p:sp>
+      <p:pic>
+        <p:nvPicPr>
+          <p:cNvPr id="53" name="Image 10" descr="preencoded.png">    </p:cNvPr>
+          <p:cNvPicPr>
+            <a:picLocks noChangeAspect="1"/>
+          </p:cNvPicPr>
+          <p:nvPr/>
+        </p:nvPicPr>
+        <p:blipFill>
+          <a:blip r:embed="rId11"/>
+          <a:stretch>
+            <a:fillRect/>
+          </a:stretch>
+        </p:blipFill>
+        <p:spPr>
+          <a:xfrm>
+            <a:off x="8714232" y="4407408"/>
+            <a:ext cx="502920" cy="502920"/>
+          </a:xfrm>
+          <a:prstGeom prst="rect">
+            <a:avLst/>
+          </a:prstGeom>
+        </p:spPr>
+      </p:pic>
+      <p:sp>
+        <p:nvSpPr>
+          <p:cNvPr id="54" name="Text 41"/>
+          <p:cNvSpPr txBox="1"/>
+          <p:nvPr/>
+        </p:nvSpPr>
+        <p:spPr>
+          <a:xfrm>
+            <a:off x="6611112" y="5001768"/>
+            <a:ext cx="4709160" cy="566928"/>
+          </a:xfrm>
+          <a:prstGeom prst="rect">
+            <a:avLst/>
+          </a:prstGeom>
+          <a:noFill/>
+          <a:ln/>
+        </p:spPr>
+        <p:txBody>
+          <a:bodyPr wrap="square" lIns="0" tIns="0" rIns="0" bIns="0" rtlCol="0" anchor="t"/>
+          <a:lstStyle/>
+          <a:p>
+            <a:pPr algn="ctr" indent="0" marL="0">
+              <a:buNone/>
+            </a:pPr>
+            <a:r>
+              <a:rPr lang="en-US" sz="1300" b="1" dirty="0">
+                <a:solidFill>
+                  <a:srgbClr val="4E6670"/>
+                </a:solidFill>
+                <a:latin typeface="Calibri" pitchFamily="34" charset="0"/>
+                <a:ea typeface="Calibri" pitchFamily="34" charset="-122"/>
+                <a:cs typeface="Calibri" pitchFamily="34" charset="-120"/>
+              </a:rPr>
+              <a:t>Site Visit Photo</a:t>
+            </a:r>
+            <a:endParaRPr lang="en-US" sz="1300" dirty="0"/>
+          </a:p>
+          <a:p>
+            <a:pPr algn="ctr" indent="0" marL="0">
+              <a:buNone/>
+            </a:pPr>
+            <a:r>
+              <a:rPr lang="en-US" sz="1000" dirty="0">
+                <a:solidFill>
+                  <a:srgbClr val="7B8F96"/>
+                </a:solidFill>
+                <a:latin typeface="Calibri" pitchFamily="34" charset="0"/>
+                <a:ea typeface="Calibri" pitchFamily="34" charset="-122"/>
+                <a:cs typeface="Calibri" pitchFamily="34" charset="-120"/>
+              </a:rPr>
+              <a:t>Insert photo here</a:t>
+            </a:r>
+            <a:endParaRPr lang="en-US" sz="1300" dirty="0"/>
+          </a:p>
+        </p:txBody>
+      </p:sp>
+      <p:sp>
+        <p:nvSpPr>
+          <p:cNvPr id="55" name="Text 42"/>
           <p:cNvSpPr txBox="1"/>
           <p:nvPr/>
         </p:nvSpPr>
@@ -19716,7 +19772,7 @@
       </p:sp>
       <p:sp>
         <p:nvSpPr>
-          <p:cNvPr id="54" name="Text 42"/>
+          <p:cNvPr id="56" name="Text 43"/>
           <p:cNvSpPr txBox="1"/>
           <p:nvPr/>
         </p:nvSpPr>
@@ -19872,11 +19928,11 @@
         <p:spPr>
           <a:xfrm>
             <a:off x="548640" y="1463040"/>
-            <a:ext cx="3291840" cy="4206240"/>
+            <a:ext cx="2697480" cy="4206240"/>
           </a:xfrm>
           <a:prstGeom prst="roundRect">
             <a:avLst>
-              <a:gd name="adj" fmla="val 2222"/>
+              <a:gd name="adj" fmla="val 2712"/>
             </a:avLst>
           </a:prstGeom>
           <a:solidFill>
@@ -19898,8 +19954,8 @@
         </p:nvSpPr>
         <p:spPr>
           <a:xfrm>
-            <a:off x="731520" y="1600200"/>
-            <a:ext cx="3017520" cy="274320"/>
+            <a:off x="685800" y="1572768"/>
+            <a:ext cx="2468880" cy="274320"/>
           </a:xfrm>
           <a:prstGeom prst="rect">
             <a:avLst/>
@@ -19915,7 +19971,7 @@
               <a:buNone/>
             </a:pPr>
             <a:r>
-              <a:rPr lang="en-US" sz="1300" b="1" spc="100" kern="0" dirty="0">
+              <a:rPr lang="en-US" sz="1200" b="1" spc="100" kern="0" dirty="0">
                 <a:solidFill>
                   <a:srgbClr val="B86E0C"/>
                 </a:solidFill>
@@ -19925,7 +19981,7 @@
               </a:rPr>
               <a:t>PLANNING &amp; PROCUREMENT</a:t>
             </a:r>
-            <a:endParaRPr lang="en-US" sz="1300" dirty="0"/>
+            <a:endParaRPr lang="en-US" sz="1200" dirty="0"/>
           </a:p>
         </p:txBody>
       </p:sp>
@@ -19937,8 +19993,8 @@
         </p:nvSpPr>
         <p:spPr>
           <a:xfrm>
-            <a:off x="731520" y="1874520"/>
-            <a:ext cx="3017520" cy="274320"/>
+            <a:off x="685800" y="1828800"/>
+            <a:ext cx="2468880" cy="274320"/>
           </a:xfrm>
           <a:prstGeom prst="rect">
             <a:avLst/>
@@ -19976,12 +20032,12 @@
         </p:nvSpPr>
         <p:spPr>
           <a:xfrm>
-            <a:off x="731520" y="2286000"/>
-            <a:ext cx="2926080" cy="1463040"/>
+            <a:off x="685800" y="2194560"/>
+            <a:ext cx="2423160" cy="1600200"/>
           </a:xfrm>
           <a:prstGeom prst="roundRect">
             <a:avLst>
-              <a:gd name="adj" fmla="val 5000"/>
+              <a:gd name="adj" fmla="val 4571"/>
             </a:avLst>
           </a:prstGeom>
           <a:solidFill>
@@ -20010,8 +20066,8 @@
         </p:nvSpPr>
         <p:spPr>
           <a:xfrm>
-            <a:off x="896112" y="2468880"/>
-            <a:ext cx="502920" cy="502920"/>
+            <a:off x="822960" y="2359152"/>
+            <a:ext cx="457200" cy="457200"/>
           </a:xfrm>
           <a:prstGeom prst="ellipse">
             <a:avLst/>
@@ -20043,8 +20099,8 @@
         </p:blipFill>
         <p:spPr>
           <a:xfrm>
-            <a:off x="1016813" y="2589581"/>
-            <a:ext cx="261518" cy="261518"/>
+            <a:off x="932688" y="2468880"/>
+            <a:ext cx="237744" cy="237744"/>
           </a:xfrm>
           <a:prstGeom prst="rect">
             <a:avLst/>
@@ -20059,8 +20115,8 @@
         </p:nvSpPr>
         <p:spPr>
           <a:xfrm>
-            <a:off x="1508760" y="2468880"/>
-            <a:ext cx="2103120" cy="502920"/>
+            <a:off x="1371600" y="2304288"/>
+            <a:ext cx="1691640" cy="566928"/>
           </a:xfrm>
           <a:prstGeom prst="rect">
             <a:avLst/>
@@ -20076,7 +20132,7 @@
               <a:buNone/>
             </a:pPr>
             <a:r>
-              <a:rPr lang="en-US" sz="1500" b="1" dirty="0">
+              <a:rPr lang="en-US" sz="1400" b="1" dirty="0">
                 <a:solidFill>
                   <a:srgbClr val="1B2B34"/>
                 </a:solidFill>
@@ -20086,7 +20142,7 @@
               </a:rPr>
               <a:t>1  Procurement</a:t>
             </a:r>
-            <a:endParaRPr lang="en-US" sz="1500" dirty="0"/>
+            <a:endParaRPr lang="en-US" sz="1400" dirty="0"/>
           </a:p>
         </p:txBody>
       </p:sp>
@@ -20098,8 +20154,8 @@
         </p:nvSpPr>
         <p:spPr>
           <a:xfrm>
-            <a:off x="896112" y="3090672"/>
-            <a:ext cx="2651760" cy="548640"/>
+            <a:off x="822960" y="2971800"/>
+            <a:ext cx="2194560" cy="685800"/>
           </a:xfrm>
           <a:prstGeom prst="rect">
             <a:avLst/>
@@ -20115,7 +20171,7 @@
               <a:buNone/>
             </a:pPr>
             <a:r>
-              <a:rPr lang="en-US" sz="1250" dirty="0">
+              <a:rPr lang="en-US" sz="1200" dirty="0">
                 <a:solidFill>
                   <a:srgbClr val="5B6770"/>
                 </a:solidFill>
@@ -20125,7 +20181,7 @@
               </a:rPr>
               <a:t>Equipment &amp; materials sourced</a:t>
             </a:r>
-            <a:endParaRPr lang="en-US" sz="1250" dirty="0"/>
+            <a:endParaRPr lang="en-US" sz="1200" dirty="0"/>
           </a:p>
         </p:txBody>
       </p:sp>
@@ -20137,12 +20193,12 @@
         </p:nvSpPr>
         <p:spPr>
           <a:xfrm>
-            <a:off x="731520" y="3931920"/>
-            <a:ext cx="2926080" cy="1463040"/>
+            <a:off x="685800" y="3931920"/>
+            <a:ext cx="2423160" cy="1600200"/>
           </a:xfrm>
           <a:prstGeom prst="roundRect">
             <a:avLst>
-              <a:gd name="adj" fmla="val 5000"/>
+              <a:gd name="adj" fmla="val 4571"/>
             </a:avLst>
           </a:prstGeom>
           <a:solidFill>
@@ -20171,8 +20227,8 @@
         </p:nvSpPr>
         <p:spPr>
           <a:xfrm>
-            <a:off x="896112" y="4114800"/>
-            <a:ext cx="502920" cy="502920"/>
+            <a:off x="822960" y="4096512"/>
+            <a:ext cx="457200" cy="457200"/>
           </a:xfrm>
           <a:prstGeom prst="ellipse">
             <a:avLst/>
@@ -20204,8 +20260,8 @@
         </p:blipFill>
         <p:spPr>
           <a:xfrm>
-            <a:off x="1016813" y="4235501"/>
-            <a:ext cx="261518" cy="261518"/>
+            <a:off x="932688" y="4206240"/>
+            <a:ext cx="237744" cy="237744"/>
           </a:xfrm>
           <a:prstGeom prst="rect">
             <a:avLst/>
@@ -20220,8 +20276,8 @@
         </p:nvSpPr>
         <p:spPr>
           <a:xfrm>
-            <a:off x="1508760" y="4114800"/>
-            <a:ext cx="2103120" cy="502920"/>
+            <a:off x="1371600" y="4041648"/>
+            <a:ext cx="1691640" cy="566928"/>
           </a:xfrm>
           <a:prstGeom prst="rect">
             <a:avLst/>
@@ -20237,7 +20293,7 @@
               <a:buNone/>
             </a:pPr>
             <a:r>
-              <a:rPr lang="en-US" sz="1500" b="1" dirty="0">
+              <a:rPr lang="en-US" sz="1400" b="1" dirty="0">
                 <a:solidFill>
                   <a:srgbClr val="1B2B34"/>
                 </a:solidFill>
@@ -20247,7 +20303,7 @@
               </a:rPr>
               <a:t>2  Vendor coordination</a:t>
             </a:r>
-            <a:endParaRPr lang="en-US" sz="1500" dirty="0"/>
+            <a:endParaRPr lang="en-US" sz="1400" dirty="0"/>
           </a:p>
         </p:txBody>
       </p:sp>
@@ -20259,8 +20315,8 @@
         </p:nvSpPr>
         <p:spPr>
           <a:xfrm>
-            <a:off x="896112" y="4736592"/>
-            <a:ext cx="2651760" cy="548640"/>
+            <a:off x="822960" y="4709160"/>
+            <a:ext cx="2194560" cy="685800"/>
           </a:xfrm>
           <a:prstGeom prst="rect">
             <a:avLst/>
@@ -20276,7 +20332,7 @@
               <a:buNone/>
             </a:pPr>
             <a:r>
-              <a:rPr lang="en-US" sz="1250" dirty="0">
+              <a:rPr lang="en-US" sz="1200" dirty="0">
                 <a:solidFill>
                   <a:srgbClr val="5B6770"/>
                 </a:solidFill>
@@ -20286,7 +20342,7 @@
               </a:rPr>
               <a:t>Supply &amp; installation aligned with vendors</a:t>
             </a:r>
-            <a:endParaRPr lang="en-US" sz="1250" dirty="0"/>
+            <a:endParaRPr lang="en-US" sz="1200" dirty="0"/>
           </a:p>
         </p:txBody>
       </p:sp>
@@ -20298,8 +20354,8 @@
         </p:nvSpPr>
         <p:spPr>
           <a:xfrm>
-            <a:off x="3931920" y="3383280"/>
-            <a:ext cx="502920" cy="411480"/>
+            <a:off x="3291840" y="3383280"/>
+            <a:ext cx="320040" cy="365760"/>
           </a:xfrm>
           <a:prstGeom prst="rightArrow">
             <a:avLst/>
@@ -20323,8 +20379,8 @@
         </p:nvSpPr>
         <p:spPr>
           <a:xfrm>
-            <a:off x="4526280" y="1463040"/>
-            <a:ext cx="7114032" cy="4206240"/>
+            <a:off x="3657600" y="1463040"/>
+            <a:ext cx="4754880" cy="4206240"/>
           </a:xfrm>
           <a:prstGeom prst="roundRect">
             <a:avLst>
@@ -20350,8 +20406,8 @@
         </p:nvSpPr>
         <p:spPr>
           <a:xfrm>
-            <a:off x="4709160" y="1600200"/>
-            <a:ext cx="4572000" cy="274320"/>
+            <a:off x="3794760" y="1572768"/>
+            <a:ext cx="4480560" cy="274320"/>
           </a:xfrm>
           <a:prstGeom prst="rect">
             <a:avLst/>
@@ -20367,7 +20423,7 @@
               <a:buNone/>
             </a:pPr>
             <a:r>
-              <a:rPr lang="en-US" sz="1300" b="1" spc="100" kern="0" dirty="0">
+              <a:rPr lang="en-US" sz="1200" b="1" spc="100" kern="0" dirty="0">
                 <a:solidFill>
                   <a:srgbClr val="0E5E6F"/>
                 </a:solidFill>
@@ -20377,7 +20433,7 @@
               </a:rPr>
               <a:t>ON-SITE INSTALLATION</a:t>
             </a:r>
-            <a:endParaRPr lang="en-US" sz="1300" dirty="0"/>
+            <a:endParaRPr lang="en-US" sz="1200" dirty="0"/>
           </a:p>
         </p:txBody>
       </p:sp>
@@ -20389,8 +20445,8 @@
         </p:nvSpPr>
         <p:spPr>
           <a:xfrm>
-            <a:off x="4709160" y="1874520"/>
-            <a:ext cx="4572000" cy="274320"/>
+            <a:off x="3794760" y="1828800"/>
+            <a:ext cx="4480560" cy="274320"/>
           </a:xfrm>
           <a:prstGeom prst="rect">
             <a:avLst/>
@@ -20428,12 +20484,12 @@
         </p:nvSpPr>
         <p:spPr>
           <a:xfrm>
-            <a:off x="4709160" y="2286000"/>
-            <a:ext cx="2148840" cy="1463040"/>
+            <a:off x="3794760" y="2194560"/>
+            <a:ext cx="2194560" cy="1051560"/>
           </a:xfrm>
           <a:prstGeom prst="roundRect">
             <a:avLst>
-              <a:gd name="adj" fmla="val 5000"/>
+              <a:gd name="adj" fmla="val 6957"/>
             </a:avLst>
           </a:prstGeom>
           <a:solidFill>
@@ -20462,8 +20518,8 @@
         </p:nvSpPr>
         <p:spPr>
           <a:xfrm>
-            <a:off x="4873752" y="2468880"/>
-            <a:ext cx="502920" cy="502920"/>
+            <a:off x="3922776" y="2322576"/>
+            <a:ext cx="411480" cy="411480"/>
           </a:xfrm>
           <a:prstGeom prst="ellipse">
             <a:avLst/>
@@ -20495,8 +20551,8 @@
         </p:blipFill>
         <p:spPr>
           <a:xfrm>
-            <a:off x="4994453" y="2589581"/>
-            <a:ext cx="261518" cy="261518"/>
+            <a:off x="4021531" y="2421331"/>
+            <a:ext cx="213970" cy="213970"/>
           </a:xfrm>
           <a:prstGeom prst="rect">
             <a:avLst/>
@@ -20511,8 +20567,8 @@
         </p:nvSpPr>
         <p:spPr>
           <a:xfrm>
-            <a:off x="6400800" y="2423160"/>
-            <a:ext cx="320040" cy="320040"/>
+            <a:off x="5623560" y="2286000"/>
+            <a:ext cx="274320" cy="274320"/>
           </a:xfrm>
           <a:prstGeom prst="rect">
             <a:avLst/>
@@ -20528,7 +20584,7 @@
               <a:buNone/>
             </a:pPr>
             <a:r>
-              <a:rPr lang="en-US" sz="1400" b="1" dirty="0">
+              <a:rPr lang="en-US" sz="1300" b="1" dirty="0">
                 <a:solidFill>
                   <a:srgbClr val="2F9AAE"/>
                 </a:solidFill>
@@ -20538,7 +20594,7 @@
               </a:rPr>
               <a:t>3</a:t>
             </a:r>
-            <a:endParaRPr lang="en-US" sz="1400" dirty="0"/>
+            <a:endParaRPr lang="en-US" sz="1300" dirty="0"/>
           </a:p>
         </p:txBody>
       </p:sp>
@@ -20550,8 +20606,47 @@
         </p:nvSpPr>
         <p:spPr>
           <a:xfrm>
-            <a:off x="4873752" y="3035808"/>
-            <a:ext cx="1874520" cy="320040"/>
+            <a:off x="4416552" y="2267712"/>
+            <a:ext cx="1234440" cy="530352"/>
+          </a:xfrm>
+          <a:prstGeom prst="rect">
+            <a:avLst/>
+          </a:prstGeom>
+          <a:noFill/>
+          <a:ln/>
+        </p:spPr>
+        <p:txBody>
+          <a:bodyPr wrap="square" lIns="0" tIns="0" rIns="0" bIns="0" rtlCol="0" anchor="ctr"/>
+          <a:lstStyle/>
+          <a:p>
+            <a:pPr indent="0" marL="0">
+              <a:buNone/>
+            </a:pPr>
+            <a:r>
+              <a:rPr lang="en-US" sz="1300" b="1" dirty="0">
+                <a:solidFill>
+                  <a:srgbClr val="1B2B34"/>
+                </a:solidFill>
+                <a:latin typeface="Calibri" pitchFamily="34" charset="0"/>
+                <a:ea typeface="Calibri" pitchFamily="34" charset="-122"/>
+                <a:cs typeface="Calibri" pitchFamily="34" charset="-120"/>
+              </a:rPr>
+              <a:t>Site preparation</a:t>
+            </a:r>
+            <a:endParaRPr lang="en-US" sz="1300" dirty="0"/>
+          </a:p>
+        </p:txBody>
+      </p:sp>
+      <p:sp>
+        <p:nvSpPr>
+          <p:cNvPr id="26" name="Text 21"/>
+          <p:cNvSpPr txBox="1"/>
+          <p:nvPr/>
+        </p:nvSpPr>
+        <p:spPr>
+          <a:xfrm>
+            <a:off x="3922776" y="2852928"/>
+            <a:ext cx="2011680" cy="320040"/>
           </a:xfrm>
           <a:prstGeom prst="rect">
             <a:avLst/>
@@ -20567,46 +20662,7 @@
               <a:buNone/>
             </a:pPr>
             <a:r>
-              <a:rPr lang="en-US" sz="1450" b="1" dirty="0">
-                <a:solidFill>
-                  <a:srgbClr val="1B2B34"/>
-                </a:solidFill>
-                <a:latin typeface="Calibri" pitchFamily="34" charset="0"/>
-                <a:ea typeface="Calibri" pitchFamily="34" charset="-122"/>
-                <a:cs typeface="Calibri" pitchFamily="34" charset="-120"/>
-              </a:rPr>
-              <a:t>Site preparation</a:t>
-            </a:r>
-            <a:endParaRPr lang="en-US" sz="1450" dirty="0"/>
-          </a:p>
-        </p:txBody>
-      </p:sp>
-      <p:sp>
-        <p:nvSpPr>
-          <p:cNvPr id="26" name="Text 21"/>
-          <p:cNvSpPr txBox="1"/>
-          <p:nvPr/>
-        </p:nvSpPr>
-        <p:spPr>
-          <a:xfrm>
-            <a:off x="4873752" y="3337560"/>
-            <a:ext cx="1874520" cy="320040"/>
-          </a:xfrm>
-          <a:prstGeom prst="rect">
-            <a:avLst/>
-          </a:prstGeom>
-          <a:noFill/>
-          <a:ln/>
-        </p:spPr>
-        <p:txBody>
-          <a:bodyPr wrap="square" lIns="0" tIns="0" rIns="0" bIns="0" rtlCol="0" anchor="t"/>
-          <a:lstStyle/>
-          <a:p>
-            <a:pPr indent="0" marL="0">
-              <a:buNone/>
-            </a:pPr>
-            <a:r>
-              <a:rPr lang="en-US" sz="1200" dirty="0">
+              <a:rPr lang="en-US" sz="1150" dirty="0">
                 <a:solidFill>
                   <a:srgbClr val="5B6770"/>
                 </a:solidFill>
@@ -20616,7 +20672,7 @@
               </a:rPr>
               <a:t>Rooftop &amp; location readied</a:t>
             </a:r>
-            <a:endParaRPr lang="en-US" sz="1200" dirty="0"/>
+            <a:endParaRPr lang="en-US" sz="1150" dirty="0"/>
           </a:p>
         </p:txBody>
       </p:sp>
@@ -20628,12 +20684,12 @@
         </p:nvSpPr>
         <p:spPr>
           <a:xfrm>
-            <a:off x="6986016" y="2286000"/>
-            <a:ext cx="2148840" cy="1463040"/>
+            <a:off x="6080760" y="2194560"/>
+            <a:ext cx="2194560" cy="1051560"/>
           </a:xfrm>
           <a:prstGeom prst="roundRect">
             <a:avLst>
-              <a:gd name="adj" fmla="val 5000"/>
+              <a:gd name="adj" fmla="val 6957"/>
             </a:avLst>
           </a:prstGeom>
           <a:solidFill>
@@ -20662,8 +20718,8 @@
         </p:nvSpPr>
         <p:spPr>
           <a:xfrm>
-            <a:off x="7150608" y="2468880"/>
-            <a:ext cx="502920" cy="502920"/>
+            <a:off x="6208776" y="2322576"/>
+            <a:ext cx="411480" cy="411480"/>
           </a:xfrm>
           <a:prstGeom prst="ellipse">
             <a:avLst/>
@@ -20695,8 +20751,8 @@
         </p:blipFill>
         <p:spPr>
           <a:xfrm>
-            <a:off x="7271309" y="2589581"/>
-            <a:ext cx="261518" cy="261518"/>
+            <a:off x="6307531" y="2421331"/>
+            <a:ext cx="213970" cy="213970"/>
           </a:xfrm>
           <a:prstGeom prst="rect">
             <a:avLst/>
@@ -20711,8 +20767,8 @@
         </p:nvSpPr>
         <p:spPr>
           <a:xfrm>
-            <a:off x="8677656" y="2423160"/>
-            <a:ext cx="320040" cy="320040"/>
+            <a:off x="7909560" y="2286000"/>
+            <a:ext cx="274320" cy="274320"/>
           </a:xfrm>
           <a:prstGeom prst="rect">
             <a:avLst/>
@@ -20728,7 +20784,7 @@
               <a:buNone/>
             </a:pPr>
             <a:r>
-              <a:rPr lang="en-US" sz="1400" b="1" dirty="0">
+              <a:rPr lang="en-US" sz="1300" b="1" dirty="0">
                 <a:solidFill>
                   <a:srgbClr val="2F9AAE"/>
                 </a:solidFill>
@@ -20738,7 +20794,7 @@
               </a:rPr>
               <a:t>4</a:t>
             </a:r>
-            <a:endParaRPr lang="en-US" sz="1400" dirty="0"/>
+            <a:endParaRPr lang="en-US" sz="1300" dirty="0"/>
           </a:p>
         </p:txBody>
       </p:sp>
@@ -20750,8 +20806,47 @@
         </p:nvSpPr>
         <p:spPr>
           <a:xfrm>
-            <a:off x="7150608" y="3035808"/>
-            <a:ext cx="1874520" cy="320040"/>
+            <a:off x="6702552" y="2267712"/>
+            <a:ext cx="1234440" cy="530352"/>
+          </a:xfrm>
+          <a:prstGeom prst="rect">
+            <a:avLst/>
+          </a:prstGeom>
+          <a:noFill/>
+          <a:ln/>
+        </p:spPr>
+        <p:txBody>
+          <a:bodyPr wrap="square" lIns="0" tIns="0" rIns="0" bIns="0" rtlCol="0" anchor="ctr"/>
+          <a:lstStyle/>
+          <a:p>
+            <a:pPr indent="0" marL="0">
+              <a:buNone/>
+            </a:pPr>
+            <a:r>
+              <a:rPr lang="en-US" sz="1300" b="1" dirty="0">
+                <a:solidFill>
+                  <a:srgbClr val="1B2B34"/>
+                </a:solidFill>
+                <a:latin typeface="Calibri" pitchFamily="34" charset="0"/>
+                <a:ea typeface="Calibri" pitchFamily="34" charset="-122"/>
+                <a:cs typeface="Calibri" pitchFamily="34" charset="-120"/>
+              </a:rPr>
+              <a:t>Solar installation</a:t>
+            </a:r>
+            <a:endParaRPr lang="en-US" sz="1300" dirty="0"/>
+          </a:p>
+        </p:txBody>
+      </p:sp>
+      <p:sp>
+        <p:nvSpPr>
+          <p:cNvPr id="32" name="Text 26"/>
+          <p:cNvSpPr txBox="1"/>
+          <p:nvPr/>
+        </p:nvSpPr>
+        <p:spPr>
+          <a:xfrm>
+            <a:off x="6208776" y="2852928"/>
+            <a:ext cx="2011680" cy="320040"/>
           </a:xfrm>
           <a:prstGeom prst="rect">
             <a:avLst/>
@@ -20767,46 +20862,7 @@
               <a:buNone/>
             </a:pPr>
             <a:r>
-              <a:rPr lang="en-US" sz="1450" b="1" dirty="0">
-                <a:solidFill>
-                  <a:srgbClr val="1B2B34"/>
-                </a:solidFill>
-                <a:latin typeface="Calibri" pitchFamily="34" charset="0"/>
-                <a:ea typeface="Calibri" pitchFamily="34" charset="-122"/>
-                <a:cs typeface="Calibri" pitchFamily="34" charset="-120"/>
-              </a:rPr>
-              <a:t>Solar installation</a:t>
-            </a:r>
-            <a:endParaRPr lang="en-US" sz="1450" dirty="0"/>
-          </a:p>
-        </p:txBody>
-      </p:sp>
-      <p:sp>
-        <p:nvSpPr>
-          <p:cNvPr id="32" name="Text 26"/>
-          <p:cNvSpPr txBox="1"/>
-          <p:nvPr/>
-        </p:nvSpPr>
-        <p:spPr>
-          <a:xfrm>
-            <a:off x="7150608" y="3337560"/>
-            <a:ext cx="1874520" cy="320040"/>
-          </a:xfrm>
-          <a:prstGeom prst="rect">
-            <a:avLst/>
-          </a:prstGeom>
-          <a:noFill/>
-          <a:ln/>
-        </p:spPr>
-        <p:txBody>
-          <a:bodyPr wrap="square" lIns="0" tIns="0" rIns="0" bIns="0" rtlCol="0" anchor="t"/>
-          <a:lstStyle/>
-          <a:p>
-            <a:pPr indent="0" marL="0">
-              <a:buNone/>
-            </a:pPr>
-            <a:r>
-              <a:rPr lang="en-US" sz="1200" dirty="0">
+              <a:rPr lang="en-US" sz="1150" dirty="0">
                 <a:solidFill>
                   <a:srgbClr val="5B6770"/>
                 </a:solidFill>
@@ -20816,7 +20872,7 @@
               </a:rPr>
               <a:t>Panels, battery &amp; inverter</a:t>
             </a:r>
-            <a:endParaRPr lang="en-US" sz="1200" dirty="0"/>
+            <a:endParaRPr lang="en-US" sz="1150" dirty="0"/>
           </a:p>
         </p:txBody>
       </p:sp>
@@ -20828,12 +20884,12 @@
         </p:nvSpPr>
         <p:spPr>
           <a:xfrm>
-            <a:off x="9262872" y="2286000"/>
-            <a:ext cx="2148840" cy="1463040"/>
+            <a:off x="3794760" y="3337560"/>
+            <a:ext cx="2194560" cy="1051560"/>
           </a:xfrm>
           <a:prstGeom prst="roundRect">
             <a:avLst>
-              <a:gd name="adj" fmla="val 5000"/>
+              <a:gd name="adj" fmla="val 6957"/>
             </a:avLst>
           </a:prstGeom>
           <a:solidFill>
@@ -20862,8 +20918,8 @@
         </p:nvSpPr>
         <p:spPr>
           <a:xfrm>
-            <a:off x="9427464" y="2468880"/>
-            <a:ext cx="502920" cy="502920"/>
+            <a:off x="3922776" y="3465576"/>
+            <a:ext cx="411480" cy="411480"/>
           </a:xfrm>
           <a:prstGeom prst="ellipse">
             <a:avLst/>
@@ -20895,8 +20951,8 @@
         </p:blipFill>
         <p:spPr>
           <a:xfrm>
-            <a:off x="9548165" y="2589581"/>
-            <a:ext cx="261518" cy="261518"/>
+            <a:off x="4021531" y="3564331"/>
+            <a:ext cx="213970" cy="213970"/>
           </a:xfrm>
           <a:prstGeom prst="rect">
             <a:avLst/>
@@ -20911,8 +20967,8 @@
         </p:nvSpPr>
         <p:spPr>
           <a:xfrm>
-            <a:off x="10954512" y="2423160"/>
-            <a:ext cx="320040" cy="320040"/>
+            <a:off x="5623560" y="3429000"/>
+            <a:ext cx="274320" cy="274320"/>
           </a:xfrm>
           <a:prstGeom prst="rect">
             <a:avLst/>
@@ -20928,7 +20984,7 @@
               <a:buNone/>
             </a:pPr>
             <a:r>
-              <a:rPr lang="en-US" sz="1400" b="1" dirty="0">
+              <a:rPr lang="en-US" sz="1300" b="1" dirty="0">
                 <a:solidFill>
                   <a:srgbClr val="2F9AAE"/>
                 </a:solidFill>
@@ -20938,7 +20994,7 @@
               </a:rPr>
               <a:t>5</a:t>
             </a:r>
-            <a:endParaRPr lang="en-US" sz="1400" dirty="0"/>
+            <a:endParaRPr lang="en-US" sz="1300" dirty="0"/>
           </a:p>
         </p:txBody>
       </p:sp>
@@ -20950,8 +21006,47 @@
         </p:nvSpPr>
         <p:spPr>
           <a:xfrm>
-            <a:off x="9427464" y="3035808"/>
-            <a:ext cx="1874520" cy="320040"/>
+            <a:off x="4416552" y="3410712"/>
+            <a:ext cx="1234440" cy="530352"/>
+          </a:xfrm>
+          <a:prstGeom prst="rect">
+            <a:avLst/>
+          </a:prstGeom>
+          <a:noFill/>
+          <a:ln/>
+        </p:spPr>
+        <p:txBody>
+          <a:bodyPr wrap="square" lIns="0" tIns="0" rIns="0" bIns="0" rtlCol="0" anchor="ctr"/>
+          <a:lstStyle/>
+          <a:p>
+            <a:pPr indent="0" marL="0">
+              <a:buNone/>
+            </a:pPr>
+            <a:r>
+              <a:rPr lang="en-US" sz="1300" b="1" dirty="0">
+                <a:solidFill>
+                  <a:srgbClr val="1B2B34"/>
+                </a:solidFill>
+                <a:latin typeface="Calibri" pitchFamily="34" charset="0"/>
+                <a:ea typeface="Calibri" pitchFamily="34" charset="-122"/>
+                <a:cs typeface="Calibri" pitchFamily="34" charset="-120"/>
+              </a:rPr>
+              <a:t>RO installation</a:t>
+            </a:r>
+            <a:endParaRPr lang="en-US" sz="1300" dirty="0"/>
+          </a:p>
+        </p:txBody>
+      </p:sp>
+      <p:sp>
+        <p:nvSpPr>
+          <p:cNvPr id="38" name="Text 31"/>
+          <p:cNvSpPr txBox="1"/>
+          <p:nvPr/>
+        </p:nvSpPr>
+        <p:spPr>
+          <a:xfrm>
+            <a:off x="3922776" y="3995928"/>
+            <a:ext cx="2011680" cy="320040"/>
           </a:xfrm>
           <a:prstGeom prst="rect">
             <a:avLst/>
@@ -20967,46 +21062,7 @@
               <a:buNone/>
             </a:pPr>
             <a:r>
-              <a:rPr lang="en-US" sz="1450" b="1" dirty="0">
-                <a:solidFill>
-                  <a:srgbClr val="1B2B34"/>
-                </a:solidFill>
-                <a:latin typeface="Calibri" pitchFamily="34" charset="0"/>
-                <a:ea typeface="Calibri" pitchFamily="34" charset="-122"/>
-                <a:cs typeface="Calibri" pitchFamily="34" charset="-120"/>
-              </a:rPr>
-              <a:t>RO installation</a:t>
-            </a:r>
-            <a:endParaRPr lang="en-US" sz="1450" dirty="0"/>
-          </a:p>
-        </p:txBody>
-      </p:sp>
-      <p:sp>
-        <p:nvSpPr>
-          <p:cNvPr id="38" name="Text 31"/>
-          <p:cNvSpPr txBox="1"/>
-          <p:nvPr/>
-        </p:nvSpPr>
-        <p:spPr>
-          <a:xfrm>
-            <a:off x="9427464" y="3337560"/>
-            <a:ext cx="1874520" cy="320040"/>
-          </a:xfrm>
-          <a:prstGeom prst="rect">
-            <a:avLst/>
-          </a:prstGeom>
-          <a:noFill/>
-          <a:ln/>
-        </p:spPr>
-        <p:txBody>
-          <a:bodyPr wrap="square" lIns="0" tIns="0" rIns="0" bIns="0" rtlCol="0" anchor="t"/>
-          <a:lstStyle/>
-          <a:p>
-            <a:pPr indent="0" marL="0">
-              <a:buNone/>
-            </a:pPr>
-            <a:r>
-              <a:rPr lang="en-US" sz="1200" dirty="0">
+              <a:rPr lang="en-US" sz="1150" dirty="0">
                 <a:solidFill>
                   <a:srgbClr val="5B6770"/>
                 </a:solidFill>
@@ -21016,7 +21072,7 @@
               </a:rPr>
               <a:t>Purifier, storage &amp; cooler</a:t>
             </a:r>
-            <a:endParaRPr lang="en-US" sz="1200" dirty="0"/>
+            <a:endParaRPr lang="en-US" sz="1150" dirty="0"/>
           </a:p>
         </p:txBody>
       </p:sp>
@@ -21028,12 +21084,12 @@
         </p:nvSpPr>
         <p:spPr>
           <a:xfrm>
-            <a:off x="4709160" y="3931920"/>
-            <a:ext cx="2148840" cy="1463040"/>
+            <a:off x="6080760" y="3337560"/>
+            <a:ext cx="2194560" cy="1051560"/>
           </a:xfrm>
           <a:prstGeom prst="roundRect">
             <a:avLst>
-              <a:gd name="adj" fmla="val 5000"/>
+              <a:gd name="adj" fmla="val 6957"/>
             </a:avLst>
           </a:prstGeom>
           <a:solidFill>
@@ -21062,8 +21118,8 @@
         </p:nvSpPr>
         <p:spPr>
           <a:xfrm>
-            <a:off x="4873752" y="4114800"/>
-            <a:ext cx="502920" cy="502920"/>
+            <a:off x="6208776" y="3465576"/>
+            <a:ext cx="411480" cy="411480"/>
           </a:xfrm>
           <a:prstGeom prst="ellipse">
             <a:avLst/>
@@ -21095,8 +21151,8 @@
         </p:blipFill>
         <p:spPr>
           <a:xfrm>
-            <a:off x="4994453" y="4235501"/>
-            <a:ext cx="261518" cy="261518"/>
+            <a:off x="6307531" y="3564331"/>
+            <a:ext cx="213970" cy="213970"/>
           </a:xfrm>
           <a:prstGeom prst="rect">
             <a:avLst/>
@@ -21111,8 +21167,8 @@
         </p:nvSpPr>
         <p:spPr>
           <a:xfrm>
-            <a:off x="6400800" y="4069080"/>
-            <a:ext cx="320040" cy="320040"/>
+            <a:off x="7909560" y="3429000"/>
+            <a:ext cx="274320" cy="274320"/>
           </a:xfrm>
           <a:prstGeom prst="rect">
             <a:avLst/>
@@ -21128,7 +21184,7 @@
               <a:buNone/>
             </a:pPr>
             <a:r>
-              <a:rPr lang="en-US" sz="1400" b="1" dirty="0">
+              <a:rPr lang="en-US" sz="1300" b="1" dirty="0">
                 <a:solidFill>
                   <a:srgbClr val="2F9AAE"/>
                 </a:solidFill>
@@ -21138,7 +21194,7 @@
               </a:rPr>
               <a:t>6</a:t>
             </a:r>
-            <a:endParaRPr lang="en-US" sz="1400" dirty="0"/>
+            <a:endParaRPr lang="en-US" sz="1300" dirty="0"/>
           </a:p>
         </p:txBody>
       </p:sp>
@@ -21150,8 +21206,47 @@
         </p:nvSpPr>
         <p:spPr>
           <a:xfrm>
-            <a:off x="4873752" y="4681728"/>
-            <a:ext cx="1874520" cy="320040"/>
+            <a:off x="6702552" y="3410712"/>
+            <a:ext cx="1234440" cy="530352"/>
+          </a:xfrm>
+          <a:prstGeom prst="rect">
+            <a:avLst/>
+          </a:prstGeom>
+          <a:noFill/>
+          <a:ln/>
+        </p:spPr>
+        <p:txBody>
+          <a:bodyPr wrap="square" lIns="0" tIns="0" rIns="0" bIns="0" rtlCol="0" anchor="ctr"/>
+          <a:lstStyle/>
+          <a:p>
+            <a:pPr indent="0" marL="0">
+              <a:buNone/>
+            </a:pPr>
+            <a:r>
+              <a:rPr lang="en-US" sz="1300" b="1" dirty="0">
+                <a:solidFill>
+                  <a:srgbClr val="1B2B34"/>
+                </a:solidFill>
+                <a:latin typeface="Calibri" pitchFamily="34" charset="0"/>
+                <a:ea typeface="Calibri" pitchFamily="34" charset="-122"/>
+                <a:cs typeface="Calibri" pitchFamily="34" charset="-120"/>
+              </a:rPr>
+              <a:t>Plumbing &amp; electrical</a:t>
+            </a:r>
+            <a:endParaRPr lang="en-US" sz="1300" dirty="0"/>
+          </a:p>
+        </p:txBody>
+      </p:sp>
+      <p:sp>
+        <p:nvSpPr>
+          <p:cNvPr id="44" name="Text 36"/>
+          <p:cNvSpPr txBox="1"/>
+          <p:nvPr/>
+        </p:nvSpPr>
+        <p:spPr>
+          <a:xfrm>
+            <a:off x="6208776" y="3995928"/>
+            <a:ext cx="2011680" cy="320040"/>
           </a:xfrm>
           <a:prstGeom prst="rect">
             <a:avLst/>
@@ -21167,46 +21262,7 @@
               <a:buNone/>
             </a:pPr>
             <a:r>
-              <a:rPr lang="en-US" sz="1450" b="1" dirty="0">
-                <a:solidFill>
-                  <a:srgbClr val="1B2B34"/>
-                </a:solidFill>
-                <a:latin typeface="Calibri" pitchFamily="34" charset="0"/>
-                <a:ea typeface="Calibri" pitchFamily="34" charset="-122"/>
-                <a:cs typeface="Calibri" pitchFamily="34" charset="-120"/>
-              </a:rPr>
-              <a:t>Plumbing &amp; electrical</a:t>
-            </a:r>
-            <a:endParaRPr lang="en-US" sz="1450" dirty="0"/>
-          </a:p>
-        </p:txBody>
-      </p:sp>
-      <p:sp>
-        <p:nvSpPr>
-          <p:cNvPr id="44" name="Text 36"/>
-          <p:cNvSpPr txBox="1"/>
-          <p:nvPr/>
-        </p:nvSpPr>
-        <p:spPr>
-          <a:xfrm>
-            <a:off x="4873752" y="4983480"/>
-            <a:ext cx="1874520" cy="320040"/>
-          </a:xfrm>
-          <a:prstGeom prst="rect">
-            <a:avLst/>
-          </a:prstGeom>
-          <a:noFill/>
-          <a:ln/>
-        </p:spPr>
-        <p:txBody>
-          <a:bodyPr wrap="square" lIns="0" tIns="0" rIns="0" bIns="0" rtlCol="0" anchor="t"/>
-          <a:lstStyle/>
-          <a:p>
-            <a:pPr indent="0" marL="0">
-              <a:buNone/>
-            </a:pPr>
-            <a:r>
-              <a:rPr lang="en-US" sz="1200" dirty="0">
+              <a:rPr lang="en-US" sz="1150" dirty="0">
                 <a:solidFill>
                   <a:srgbClr val="5B6770"/>
                 </a:solidFill>
@@ -21216,7 +21272,7 @@
               </a:rPr>
               <a:t>Wiring, pipes &amp; connections</a:t>
             </a:r>
-            <a:endParaRPr lang="en-US" sz="1200" dirty="0"/>
+            <a:endParaRPr lang="en-US" sz="1150" dirty="0"/>
           </a:p>
         </p:txBody>
       </p:sp>
@@ -21228,12 +21284,12 @@
         </p:nvSpPr>
         <p:spPr>
           <a:xfrm>
-            <a:off x="6986016" y="3931920"/>
-            <a:ext cx="2148840" cy="1463040"/>
+            <a:off x="3794760" y="4480560"/>
+            <a:ext cx="2194560" cy="1051560"/>
           </a:xfrm>
           <a:prstGeom prst="roundRect">
             <a:avLst>
-              <a:gd name="adj" fmla="val 5000"/>
+              <a:gd name="adj" fmla="val 6957"/>
             </a:avLst>
           </a:prstGeom>
           <a:solidFill>
@@ -21262,8 +21318,8 @@
         </p:nvSpPr>
         <p:spPr>
           <a:xfrm>
-            <a:off x="7150608" y="4114800"/>
-            <a:ext cx="502920" cy="502920"/>
+            <a:off x="3922776" y="4608576"/>
+            <a:ext cx="411480" cy="411480"/>
           </a:xfrm>
           <a:prstGeom prst="ellipse">
             <a:avLst/>
@@ -21295,8 +21351,8 @@
         </p:blipFill>
         <p:spPr>
           <a:xfrm>
-            <a:off x="7271309" y="4235501"/>
-            <a:ext cx="261518" cy="261518"/>
+            <a:off x="4021531" y="4707331"/>
+            <a:ext cx="213970" cy="213970"/>
           </a:xfrm>
           <a:prstGeom prst="rect">
             <a:avLst/>
@@ -21311,8 +21367,8 @@
         </p:nvSpPr>
         <p:spPr>
           <a:xfrm>
-            <a:off x="8677656" y="4069080"/>
-            <a:ext cx="320040" cy="320040"/>
+            <a:off x="5623560" y="4572000"/>
+            <a:ext cx="274320" cy="274320"/>
           </a:xfrm>
           <a:prstGeom prst="rect">
             <a:avLst/>
@@ -21328,7 +21384,7 @@
               <a:buNone/>
             </a:pPr>
             <a:r>
-              <a:rPr lang="en-US" sz="1400" b="1" dirty="0">
+              <a:rPr lang="en-US" sz="1300" b="1" dirty="0">
                 <a:solidFill>
                   <a:srgbClr val="2F9AAE"/>
                 </a:solidFill>
@@ -21338,7 +21394,7 @@
               </a:rPr>
               <a:t>7</a:t>
             </a:r>
-            <a:endParaRPr lang="en-US" sz="1400" dirty="0"/>
+            <a:endParaRPr lang="en-US" sz="1300" dirty="0"/>
           </a:p>
         </p:txBody>
       </p:sp>
@@ -21350,8 +21406,47 @@
         </p:nvSpPr>
         <p:spPr>
           <a:xfrm>
-            <a:off x="7150608" y="4681728"/>
-            <a:ext cx="1874520" cy="320040"/>
+            <a:off x="4416552" y="4553712"/>
+            <a:ext cx="1234440" cy="530352"/>
+          </a:xfrm>
+          <a:prstGeom prst="rect">
+            <a:avLst/>
+          </a:prstGeom>
+          <a:noFill/>
+          <a:ln/>
+        </p:spPr>
+        <p:txBody>
+          <a:bodyPr wrap="square" lIns="0" tIns="0" rIns="0" bIns="0" rtlCol="0" anchor="ctr"/>
+          <a:lstStyle/>
+          <a:p>
+            <a:pPr indent="0" marL="0">
+              <a:buNone/>
+            </a:pPr>
+            <a:r>
+              <a:rPr lang="en-US" sz="1300" b="1" dirty="0">
+                <a:solidFill>
+                  <a:srgbClr val="1B2B34"/>
+                </a:solidFill>
+                <a:latin typeface="Calibri" pitchFamily="34" charset="0"/>
+                <a:ea typeface="Calibri" pitchFamily="34" charset="-122"/>
+                <a:cs typeface="Calibri" pitchFamily="34" charset="-120"/>
+              </a:rPr>
+              <a:t>System testing</a:t>
+            </a:r>
+            <a:endParaRPr lang="en-US" sz="1300" dirty="0"/>
+          </a:p>
+        </p:txBody>
+      </p:sp>
+      <p:sp>
+        <p:nvSpPr>
+          <p:cNvPr id="50" name="Text 41"/>
+          <p:cNvSpPr txBox="1"/>
+          <p:nvPr/>
+        </p:nvSpPr>
+        <p:spPr>
+          <a:xfrm>
+            <a:off x="3922776" y="5138928"/>
+            <a:ext cx="2011680" cy="320040"/>
           </a:xfrm>
           <a:prstGeom prst="rect">
             <a:avLst/>
@@ -21367,46 +21462,7 @@
               <a:buNone/>
             </a:pPr>
             <a:r>
-              <a:rPr lang="en-US" sz="1450" b="1" dirty="0">
-                <a:solidFill>
-                  <a:srgbClr val="1B2B34"/>
-                </a:solidFill>
-                <a:latin typeface="Calibri" pitchFamily="34" charset="0"/>
-                <a:ea typeface="Calibri" pitchFamily="34" charset="-122"/>
-                <a:cs typeface="Calibri" pitchFamily="34" charset="-120"/>
-              </a:rPr>
-              <a:t>System testing</a:t>
-            </a:r>
-            <a:endParaRPr lang="en-US" sz="1450" dirty="0"/>
-          </a:p>
-        </p:txBody>
-      </p:sp>
-      <p:sp>
-        <p:nvSpPr>
-          <p:cNvPr id="50" name="Text 41"/>
-          <p:cNvSpPr txBox="1"/>
-          <p:nvPr/>
-        </p:nvSpPr>
-        <p:spPr>
-          <a:xfrm>
-            <a:off x="7150608" y="4983480"/>
-            <a:ext cx="1874520" cy="320040"/>
-          </a:xfrm>
-          <a:prstGeom prst="rect">
-            <a:avLst/>
-          </a:prstGeom>
-          <a:noFill/>
-          <a:ln/>
-        </p:spPr>
-        <p:txBody>
-          <a:bodyPr wrap="square" lIns="0" tIns="0" rIns="0" bIns="0" rtlCol="0" anchor="t"/>
-          <a:lstStyle/>
-          <a:p>
-            <a:pPr indent="0" marL="0">
-              <a:buNone/>
-            </a:pPr>
-            <a:r>
-              <a:rPr lang="en-US" sz="1200" dirty="0">
+              <a:rPr lang="en-US" sz="1150" dirty="0">
                 <a:solidFill>
                   <a:srgbClr val="5B6770"/>
                 </a:solidFill>
@@ -21416,7 +21472,7 @@
               </a:rPr>
               <a:t>Full system run &amp; checked</a:t>
             </a:r>
-            <a:endParaRPr lang="en-US" sz="1200" dirty="0"/>
+            <a:endParaRPr lang="en-US" sz="1150" dirty="0"/>
           </a:p>
         </p:txBody>
       </p:sp>
@@ -21428,12 +21484,12 @@
         </p:nvSpPr>
         <p:spPr>
           <a:xfrm>
-            <a:off x="9262872" y="3931920"/>
-            <a:ext cx="2148840" cy="1463040"/>
+            <a:off x="6080760" y="4480560"/>
+            <a:ext cx="2194560" cy="1051560"/>
           </a:xfrm>
           <a:prstGeom prst="roundRect">
             <a:avLst>
-              <a:gd name="adj" fmla="val 5000"/>
+              <a:gd name="adj" fmla="val 6957"/>
             </a:avLst>
           </a:prstGeom>
           <a:solidFill>
@@ -21462,8 +21518,8 @@
         </p:nvSpPr>
         <p:spPr>
           <a:xfrm>
-            <a:off x="9427464" y="4114800"/>
-            <a:ext cx="502920" cy="502920"/>
+            <a:off x="6208776" y="4608576"/>
+            <a:ext cx="411480" cy="411480"/>
           </a:xfrm>
           <a:prstGeom prst="ellipse">
             <a:avLst/>
@@ -21495,8 +21551,8 @@
         </p:blipFill>
         <p:spPr>
           <a:xfrm>
-            <a:off x="9548165" y="4235501"/>
-            <a:ext cx="261518" cy="261518"/>
+            <a:off x="6307531" y="4707331"/>
+            <a:ext cx="213970" cy="213970"/>
           </a:xfrm>
           <a:prstGeom prst="rect">
             <a:avLst/>
@@ -21511,8 +21567,8 @@
         </p:nvSpPr>
         <p:spPr>
           <a:xfrm>
-            <a:off x="10954512" y="4069080"/>
-            <a:ext cx="320040" cy="320040"/>
+            <a:off x="7909560" y="4572000"/>
+            <a:ext cx="274320" cy="274320"/>
           </a:xfrm>
           <a:prstGeom prst="rect">
             <a:avLst/>
@@ -21528,7 +21584,7 @@
               <a:buNone/>
             </a:pPr>
             <a:r>
-              <a:rPr lang="en-US" sz="1400" b="1" dirty="0">
+              <a:rPr lang="en-US" sz="1300" b="1" dirty="0">
                 <a:solidFill>
                   <a:srgbClr val="2F9AAE"/>
                 </a:solidFill>
@@ -21538,7 +21594,7 @@
               </a:rPr>
               <a:t>8</a:t>
             </a:r>
-            <a:endParaRPr lang="en-US" sz="1400" dirty="0"/>
+            <a:endParaRPr lang="en-US" sz="1300" dirty="0"/>
           </a:p>
         </p:txBody>
       </p:sp>
@@ -21550,8 +21606,47 @@
         </p:nvSpPr>
         <p:spPr>
           <a:xfrm>
-            <a:off x="9427464" y="4681728"/>
-            <a:ext cx="1874520" cy="320040"/>
+            <a:off x="6702552" y="4553712"/>
+            <a:ext cx="1234440" cy="530352"/>
+          </a:xfrm>
+          <a:prstGeom prst="rect">
+            <a:avLst/>
+          </a:prstGeom>
+          <a:noFill/>
+          <a:ln/>
+        </p:spPr>
+        <p:txBody>
+          <a:bodyPr wrap="square" lIns="0" tIns="0" rIns="0" bIns="0" rtlCol="0" anchor="ctr"/>
+          <a:lstStyle/>
+          <a:p>
+            <a:pPr indent="0" marL="0">
+              <a:buNone/>
+            </a:pPr>
+            <a:r>
+              <a:rPr lang="en-US" sz="1300" b="1" dirty="0">
+                <a:solidFill>
+                  <a:srgbClr val="1B2B34"/>
+                </a:solidFill>
+                <a:latin typeface="Calibri" pitchFamily="34" charset="0"/>
+                <a:ea typeface="Calibri" pitchFamily="34" charset="-122"/>
+                <a:cs typeface="Calibri" pitchFamily="34" charset="-120"/>
+              </a:rPr>
+              <a:t>Quality &amp; safety check</a:t>
+            </a:r>
+            <a:endParaRPr lang="en-US" sz="1300" dirty="0"/>
+          </a:p>
+        </p:txBody>
+      </p:sp>
+      <p:sp>
+        <p:nvSpPr>
+          <p:cNvPr id="56" name="Text 46"/>
+          <p:cNvSpPr txBox="1"/>
+          <p:nvPr/>
+        </p:nvSpPr>
+        <p:spPr>
+          <a:xfrm>
+            <a:off x="6208776" y="5138928"/>
+            <a:ext cx="2011680" cy="320040"/>
           </a:xfrm>
           <a:prstGeom prst="rect">
             <a:avLst/>
@@ -21567,46 +21662,7 @@
               <a:buNone/>
             </a:pPr>
             <a:r>
-              <a:rPr lang="en-US" sz="1450" b="1" dirty="0">
-                <a:solidFill>
-                  <a:srgbClr val="1B2B34"/>
-                </a:solidFill>
-                <a:latin typeface="Calibri" pitchFamily="34" charset="0"/>
-                <a:ea typeface="Calibri" pitchFamily="34" charset="-122"/>
-                <a:cs typeface="Calibri" pitchFamily="34" charset="-120"/>
-              </a:rPr>
-              <a:t>Quality &amp; safety check</a:t>
-            </a:r>
-            <a:endParaRPr lang="en-US" sz="1450" dirty="0"/>
-          </a:p>
-        </p:txBody>
-      </p:sp>
-      <p:sp>
-        <p:nvSpPr>
-          <p:cNvPr id="56" name="Text 46"/>
-          <p:cNvSpPr txBox="1"/>
-          <p:nvPr/>
-        </p:nvSpPr>
-        <p:spPr>
-          <a:xfrm>
-            <a:off x="9427464" y="4983480"/>
-            <a:ext cx="1874520" cy="320040"/>
-          </a:xfrm>
-          <a:prstGeom prst="rect">
-            <a:avLst/>
-          </a:prstGeom>
-          <a:noFill/>
-          <a:ln/>
-        </p:spPr>
-        <p:txBody>
-          <a:bodyPr wrap="square" lIns="0" tIns="0" rIns="0" bIns="0" rtlCol="0" anchor="t"/>
-          <a:lstStyle/>
-          <a:p>
-            <a:pPr indent="0" marL="0">
-              <a:buNone/>
-            </a:pPr>
-            <a:r>
-              <a:rPr lang="en-US" sz="1200" dirty="0">
+              <a:rPr lang="en-US" sz="1150" dirty="0">
                 <a:solidFill>
                   <a:srgbClr val="5B6770"/>
                 </a:solidFill>
@@ -21616,7 +21672,7 @@
               </a:rPr>
               <a:t>Verified before use</a:t>
             </a:r>
-            <a:endParaRPr lang="en-US" sz="1200" dirty="0"/>
+            <a:endParaRPr lang="en-US" sz="1150" dirty="0"/>
           </a:p>
         </p:txBody>
       </p:sp>
@@ -21628,20 +21684,20 @@
         </p:nvSpPr>
         <p:spPr>
           <a:xfrm>
-            <a:off x="548640" y="5788152"/>
-            <a:ext cx="411480" cy="411480"/>
-          </a:xfrm>
-          <a:prstGeom prst="ellipse">
-            <a:avLst/>
-          </a:prstGeom>
-          <a:solidFill>
-            <a:srgbClr val="4A8A45"/>
-          </a:solidFill>
-          <a:ln w="12700">
-            <a:solidFill>
-              <a:srgbClr val="4A8A45"/>
-            </a:solidFill>
-            <a:prstDash val="solid"/>
+            <a:off x="8595360" y="1463040"/>
+            <a:ext cx="3044952" cy="2029968"/>
+          </a:xfrm>
+          <a:prstGeom prst="rect">
+            <a:avLst/>
+          </a:prstGeom>
+          <a:solidFill>
+            <a:srgbClr val="EEF3F4"/>
+          </a:solidFill>
+          <a:ln w="15875">
+            <a:solidFill>
+              <a:srgbClr val="8AA3AB"/>
+            </a:solidFill>
+            <a:prstDash val="dash"/>
           </a:ln>
         </p:spPr>
       </p:sp>
@@ -21661,6 +21717,216 @@
         </p:blipFill>
         <p:spPr>
           <a:xfrm>
+            <a:off x="9866376" y="1901952"/>
+            <a:ext cx="502920" cy="502920"/>
+          </a:xfrm>
+          <a:prstGeom prst="rect">
+            <a:avLst/>
+          </a:prstGeom>
+        </p:spPr>
+      </p:pic>
+      <p:sp>
+        <p:nvSpPr>
+          <p:cNvPr id="59" name="Text 48"/>
+          <p:cNvSpPr txBox="1"/>
+          <p:nvPr/>
+        </p:nvSpPr>
+        <p:spPr>
+          <a:xfrm>
+            <a:off x="8686800" y="2496312"/>
+            <a:ext cx="2862072" cy="566928"/>
+          </a:xfrm>
+          <a:prstGeom prst="rect">
+            <a:avLst/>
+          </a:prstGeom>
+          <a:noFill/>
+          <a:ln/>
+        </p:spPr>
+        <p:txBody>
+          <a:bodyPr wrap="square" lIns="0" tIns="0" rIns="0" bIns="0" rtlCol="0" anchor="t"/>
+          <a:lstStyle/>
+          <a:p>
+            <a:pPr algn="ctr" indent="0" marL="0">
+              <a:buNone/>
+            </a:pPr>
+            <a:r>
+              <a:rPr lang="en-US" sz="1300" b="1" dirty="0">
+                <a:solidFill>
+                  <a:srgbClr val="4E6670"/>
+                </a:solidFill>
+                <a:latin typeface="Calibri" pitchFamily="34" charset="0"/>
+                <a:ea typeface="Calibri" pitchFamily="34" charset="-122"/>
+                <a:cs typeface="Calibri" pitchFamily="34" charset="-120"/>
+              </a:rPr>
+              <a:t>Installation Photo</a:t>
+            </a:r>
+            <a:endParaRPr lang="en-US" sz="1300" dirty="0"/>
+          </a:p>
+          <a:p>
+            <a:pPr algn="ctr" indent="0" marL="0">
+              <a:buNone/>
+            </a:pPr>
+            <a:r>
+              <a:rPr lang="en-US" sz="1000" dirty="0">
+                <a:solidFill>
+                  <a:srgbClr val="7B8F96"/>
+                </a:solidFill>
+                <a:latin typeface="Calibri" pitchFamily="34" charset="0"/>
+                <a:ea typeface="Calibri" pitchFamily="34" charset="-122"/>
+                <a:cs typeface="Calibri" pitchFamily="34" charset="-120"/>
+              </a:rPr>
+              <a:t>Insert photo here</a:t>
+            </a:r>
+            <a:endParaRPr lang="en-US" sz="1300" dirty="0"/>
+          </a:p>
+        </p:txBody>
+      </p:sp>
+      <p:sp>
+        <p:nvSpPr>
+          <p:cNvPr id="60" name="Shape 49"/>
+          <p:cNvSpPr/>
+          <p:nvPr/>
+        </p:nvSpPr>
+        <p:spPr>
+          <a:xfrm>
+            <a:off x="8595360" y="3639312"/>
+            <a:ext cx="3044952" cy="2029968"/>
+          </a:xfrm>
+          <a:prstGeom prst="rect">
+            <a:avLst/>
+          </a:prstGeom>
+          <a:solidFill>
+            <a:srgbClr val="EEF3F4"/>
+          </a:solidFill>
+          <a:ln w="15875">
+            <a:solidFill>
+              <a:srgbClr val="8AA3AB"/>
+            </a:solidFill>
+            <a:prstDash val="dash"/>
+          </a:ln>
+        </p:spPr>
+      </p:sp>
+      <p:pic>
+        <p:nvPicPr>
+          <p:cNvPr id="61" name="Image 9" descr="preencoded.png">    </p:cNvPr>
+          <p:cNvPicPr>
+            <a:picLocks noChangeAspect="1"/>
+          </p:cNvPicPr>
+          <p:nvPr/>
+        </p:nvPicPr>
+        <p:blipFill>
+          <a:blip r:embed="rId10"/>
+          <a:stretch>
+            <a:fillRect/>
+          </a:stretch>
+        </p:blipFill>
+        <p:spPr>
+          <a:xfrm>
+            <a:off x="9866376" y="4078224"/>
+            <a:ext cx="502920" cy="502920"/>
+          </a:xfrm>
+          <a:prstGeom prst="rect">
+            <a:avLst/>
+          </a:prstGeom>
+        </p:spPr>
+      </p:pic>
+      <p:sp>
+        <p:nvSpPr>
+          <p:cNvPr id="62" name="Text 50"/>
+          <p:cNvSpPr txBox="1"/>
+          <p:nvPr/>
+        </p:nvSpPr>
+        <p:spPr>
+          <a:xfrm>
+            <a:off x="8686800" y="4672584"/>
+            <a:ext cx="2862072" cy="566928"/>
+          </a:xfrm>
+          <a:prstGeom prst="rect">
+            <a:avLst/>
+          </a:prstGeom>
+          <a:noFill/>
+          <a:ln/>
+        </p:spPr>
+        <p:txBody>
+          <a:bodyPr wrap="square" lIns="0" tIns="0" rIns="0" bIns="0" rtlCol="0" anchor="t"/>
+          <a:lstStyle/>
+          <a:p>
+            <a:pPr algn="ctr" indent="0" marL="0">
+              <a:buNone/>
+            </a:pPr>
+            <a:r>
+              <a:rPr lang="en-US" sz="1300" b="1" dirty="0">
+                <a:solidFill>
+                  <a:srgbClr val="4E6670"/>
+                </a:solidFill>
+                <a:latin typeface="Calibri" pitchFamily="34" charset="0"/>
+                <a:ea typeface="Calibri" pitchFamily="34" charset="-122"/>
+                <a:cs typeface="Calibri" pitchFamily="34" charset="-120"/>
+              </a:rPr>
+              <a:t>Testing Photo</a:t>
+            </a:r>
+            <a:endParaRPr lang="en-US" sz="1300" dirty="0"/>
+          </a:p>
+          <a:p>
+            <a:pPr algn="ctr" indent="0" marL="0">
+              <a:buNone/>
+            </a:pPr>
+            <a:r>
+              <a:rPr lang="en-US" sz="1000" dirty="0">
+                <a:solidFill>
+                  <a:srgbClr val="7B8F96"/>
+                </a:solidFill>
+                <a:latin typeface="Calibri" pitchFamily="34" charset="0"/>
+                <a:ea typeface="Calibri" pitchFamily="34" charset="-122"/>
+                <a:cs typeface="Calibri" pitchFamily="34" charset="-120"/>
+              </a:rPr>
+              <a:t>Insert photo here</a:t>
+            </a:r>
+            <a:endParaRPr lang="en-US" sz="1300" dirty="0"/>
+          </a:p>
+        </p:txBody>
+      </p:sp>
+      <p:sp>
+        <p:nvSpPr>
+          <p:cNvPr id="63" name="Shape 51"/>
+          <p:cNvSpPr/>
+          <p:nvPr/>
+        </p:nvSpPr>
+        <p:spPr>
+          <a:xfrm>
+            <a:off x="548640" y="5788152"/>
+            <a:ext cx="411480" cy="411480"/>
+          </a:xfrm>
+          <a:prstGeom prst="ellipse">
+            <a:avLst/>
+          </a:prstGeom>
+          <a:solidFill>
+            <a:srgbClr val="4A8A45"/>
+          </a:solidFill>
+          <a:ln w="12700">
+            <a:solidFill>
+              <a:srgbClr val="4A8A45"/>
+            </a:solidFill>
+            <a:prstDash val="solid"/>
+          </a:ln>
+        </p:spPr>
+      </p:sp>
+      <p:pic>
+        <p:nvPicPr>
+          <p:cNvPr id="64" name="Image 10" descr="preencoded.png">    </p:cNvPr>
+          <p:cNvPicPr>
+            <a:picLocks noChangeAspect="1"/>
+          </p:cNvPicPr>
+          <p:nvPr/>
+        </p:nvPicPr>
+        <p:blipFill>
+          <a:blip r:embed="rId11"/>
+          <a:stretch>
+            <a:fillRect/>
+          </a:stretch>
+        </p:blipFill>
+        <p:spPr>
+          <a:xfrm>
             <a:off x="659740" y="5899252"/>
             <a:ext cx="189281" cy="189281"/>
           </a:xfrm>
@@ -21671,7 +21937,7 @@
       </p:pic>
       <p:sp>
         <p:nvSpPr>
-          <p:cNvPr id="59" name="Text 48"/>
+          <p:cNvPr id="65" name="Text 52"/>
           <p:cNvSpPr txBox="1"/>
           <p:nvPr/>
         </p:nvSpPr>
@@ -21724,7 +21990,7 @@
       </p:sp>
       <p:sp>
         <p:nvSpPr>
-          <p:cNvPr id="60" name="Text 49"/>
+          <p:cNvPr id="66" name="Text 53"/>
           <p:cNvSpPr txBox="1"/>
           <p:nvPr/>
         </p:nvSpPr>
@@ -21763,7 +22029,7 @@
       </p:sp>
       <p:sp>
         <p:nvSpPr>
-          <p:cNvPr id="61" name="Text 50"/>
+          <p:cNvPr id="67" name="Text 54"/>
           <p:cNvSpPr txBox="1"/>
           <p:nvPr/>
         </p:nvSpPr>
@@ -21992,7 +22258,7 @@
                 <a:ea typeface="Calibri" pitchFamily="34" charset="-122"/>
                 <a:cs typeface="Calibri" pitchFamily="34" charset="-120"/>
               </a:rPr>
-              <a:t>Training / Community Engagement Photo</a:t>
+              <a:t>Training Photo</a:t>
             </a:r>
             <a:endParaRPr lang="en-US" sz="1300" dirty="0"/>
           </a:p>

</xml_diff>